<commit_message>
Added Healthcare IAM Lifecycle Automation
</commit_message>
<xml_diff>
--- a/09-Presentation/IAM-Healthcare-Automation-Professional.pptx
+++ b/09-Presentation/IAM-Healthcare-Automation-Professional.pptx
@@ -4,6 +4,9 @@
   <p:sldMasterIdLst>
     <p:sldMasterId id="2147483648" r:id="rId1"/>
   </p:sldMasterIdLst>
+  <p:notesMasterIdLst>
+    <p:notesMasterId r:id="rId15"/>
+  </p:notesMasterIdLst>
   <p:sldIdLst>
     <p:sldId id="268" r:id="rId2"/>
     <p:sldId id="256" r:id="rId3"/>
@@ -122,6 +125,1285 @@
     </p:ext>
   </p:extLst>
 </p:presentation>
+</file>
+
+<file path=ppt/notesMasters/notesMaster1.xml><?xml version="1.0" encoding="utf-8"?>
+<p:notesMaster xmlns:a="http://schemas.openxmlformats.org/drawingml/2006/main" xmlns:r="http://schemas.openxmlformats.org/officeDocument/2006/relationships" xmlns:p="http://schemas.openxmlformats.org/presentationml/2006/main">
+  <p:cSld>
+    <p:bg>
+      <p:bgRef idx="1001">
+        <a:schemeClr val="bg1"/>
+      </p:bgRef>
+    </p:bg>
+    <p:spTree>
+      <p:nvGrpSpPr>
+        <p:cNvPr id="1" name=""/>
+        <p:cNvGrpSpPr/>
+        <p:nvPr/>
+      </p:nvGrpSpPr>
+      <p:grpSpPr>
+        <a:xfrm>
+          <a:off x="0" y="0"/>
+          <a:ext cx="0" cy="0"/>
+          <a:chOff x="0" y="0"/>
+          <a:chExt cx="0" cy="0"/>
+        </a:xfrm>
+      </p:grpSpPr>
+      <p:sp>
+        <p:nvSpPr>
+          <p:cNvPr id="2" name="Header Placeholder 1"/>
+          <p:cNvSpPr>
+            <a:spLocks noGrp="1"/>
+          </p:cNvSpPr>
+          <p:nvPr>
+            <p:ph type="hdr" sz="quarter"/>
+          </p:nvPr>
+        </p:nvSpPr>
+        <p:spPr>
+          <a:xfrm>
+            <a:off x="0" y="0"/>
+            <a:ext cx="2971800" cy="458788"/>
+          </a:xfrm>
+          <a:prstGeom prst="rect">
+            <a:avLst/>
+          </a:prstGeom>
+        </p:spPr>
+        <p:txBody>
+          <a:bodyPr vert="horz" lIns="91440" tIns="45720" rIns="91440" bIns="45720" rtlCol="0"/>
+          <a:lstStyle>
+            <a:lvl1pPr algn="l">
+              <a:defRPr sz="1200"/>
+            </a:lvl1pPr>
+          </a:lstStyle>
+          <a:p>
+            <a:endParaRPr lang="en-US"/>
+          </a:p>
+        </p:txBody>
+      </p:sp>
+      <p:sp>
+        <p:nvSpPr>
+          <p:cNvPr id="3" name="Date Placeholder 2"/>
+          <p:cNvSpPr>
+            <a:spLocks noGrp="1"/>
+          </p:cNvSpPr>
+          <p:nvPr>
+            <p:ph type="dt" idx="1"/>
+          </p:nvPr>
+        </p:nvSpPr>
+        <p:spPr>
+          <a:xfrm>
+            <a:off x="3884613" y="0"/>
+            <a:ext cx="2971800" cy="458788"/>
+          </a:xfrm>
+          <a:prstGeom prst="rect">
+            <a:avLst/>
+          </a:prstGeom>
+        </p:spPr>
+        <p:txBody>
+          <a:bodyPr vert="horz" lIns="91440" tIns="45720" rIns="91440" bIns="45720" rtlCol="0"/>
+          <a:lstStyle>
+            <a:lvl1pPr algn="r">
+              <a:defRPr sz="1200"/>
+            </a:lvl1pPr>
+          </a:lstStyle>
+          <a:p>
+            <a:fld id="{280E9DBE-3662-4895-B281-A721E3F5222D}" type="datetimeFigureOut">
+              <a:rPr lang="en-US" smtClean="0"/>
+              <a:t>6/8/2026</a:t>
+            </a:fld>
+            <a:endParaRPr lang="en-US"/>
+          </a:p>
+        </p:txBody>
+      </p:sp>
+      <p:sp>
+        <p:nvSpPr>
+          <p:cNvPr id="4" name="Slide Image Placeholder 3"/>
+          <p:cNvSpPr>
+            <a:spLocks noGrp="1" noRot="1" noChangeAspect="1"/>
+          </p:cNvSpPr>
+          <p:nvPr>
+            <p:ph type="sldImg" idx="2"/>
+          </p:nvPr>
+        </p:nvSpPr>
+        <p:spPr>
+          <a:xfrm>
+            <a:off x="685800" y="1143000"/>
+            <a:ext cx="5486400" cy="3086100"/>
+          </a:xfrm>
+          <a:prstGeom prst="rect">
+            <a:avLst/>
+          </a:prstGeom>
+          <a:noFill/>
+          <a:ln w="12700">
+            <a:solidFill>
+              <a:prstClr val="black"/>
+            </a:solidFill>
+          </a:ln>
+        </p:spPr>
+        <p:txBody>
+          <a:bodyPr vert="horz" lIns="91440" tIns="45720" rIns="91440" bIns="45720" rtlCol="0" anchor="ctr"/>
+          <a:lstStyle/>
+          <a:p>
+            <a:endParaRPr lang="en-US"/>
+          </a:p>
+        </p:txBody>
+      </p:sp>
+      <p:sp>
+        <p:nvSpPr>
+          <p:cNvPr id="5" name="Notes Placeholder 4"/>
+          <p:cNvSpPr>
+            <a:spLocks noGrp="1"/>
+          </p:cNvSpPr>
+          <p:nvPr>
+            <p:ph type="body" sz="quarter" idx="3"/>
+          </p:nvPr>
+        </p:nvSpPr>
+        <p:spPr>
+          <a:xfrm>
+            <a:off x="685800" y="4400550"/>
+            <a:ext cx="5486400" cy="3600450"/>
+          </a:xfrm>
+          <a:prstGeom prst="rect">
+            <a:avLst/>
+          </a:prstGeom>
+        </p:spPr>
+        <p:txBody>
+          <a:bodyPr vert="horz" lIns="91440" tIns="45720" rIns="91440" bIns="45720" rtlCol="0"/>
+          <a:lstStyle/>
+          <a:p>
+            <a:pPr lvl="0"/>
+            <a:r>
+              <a:rPr lang="en-US"/>
+              <a:t>Click to edit Master text styles</a:t>
+            </a:r>
+          </a:p>
+          <a:p>
+            <a:pPr lvl="1"/>
+            <a:r>
+              <a:rPr lang="en-US"/>
+              <a:t>Second level</a:t>
+            </a:r>
+          </a:p>
+          <a:p>
+            <a:pPr lvl="2"/>
+            <a:r>
+              <a:rPr lang="en-US"/>
+              <a:t>Third level</a:t>
+            </a:r>
+          </a:p>
+          <a:p>
+            <a:pPr lvl="3"/>
+            <a:r>
+              <a:rPr lang="en-US"/>
+              <a:t>Fourth level</a:t>
+            </a:r>
+          </a:p>
+          <a:p>
+            <a:pPr lvl="4"/>
+            <a:r>
+              <a:rPr lang="en-US"/>
+              <a:t>Fifth level</a:t>
+            </a:r>
+          </a:p>
+        </p:txBody>
+      </p:sp>
+      <p:sp>
+        <p:nvSpPr>
+          <p:cNvPr id="6" name="Footer Placeholder 5"/>
+          <p:cNvSpPr>
+            <a:spLocks noGrp="1"/>
+          </p:cNvSpPr>
+          <p:nvPr>
+            <p:ph type="ftr" sz="quarter" idx="4"/>
+          </p:nvPr>
+        </p:nvSpPr>
+        <p:spPr>
+          <a:xfrm>
+            <a:off x="0" y="8685213"/>
+            <a:ext cx="2971800" cy="458787"/>
+          </a:xfrm>
+          <a:prstGeom prst="rect">
+            <a:avLst/>
+          </a:prstGeom>
+        </p:spPr>
+        <p:txBody>
+          <a:bodyPr vert="horz" lIns="91440" tIns="45720" rIns="91440" bIns="45720" rtlCol="0" anchor="b"/>
+          <a:lstStyle>
+            <a:lvl1pPr algn="l">
+              <a:defRPr sz="1200"/>
+            </a:lvl1pPr>
+          </a:lstStyle>
+          <a:p>
+            <a:endParaRPr lang="en-US"/>
+          </a:p>
+        </p:txBody>
+      </p:sp>
+      <p:sp>
+        <p:nvSpPr>
+          <p:cNvPr id="7" name="Slide Number Placeholder 6"/>
+          <p:cNvSpPr>
+            <a:spLocks noGrp="1"/>
+          </p:cNvSpPr>
+          <p:nvPr>
+            <p:ph type="sldNum" sz="quarter" idx="5"/>
+          </p:nvPr>
+        </p:nvSpPr>
+        <p:spPr>
+          <a:xfrm>
+            <a:off x="3884613" y="8685213"/>
+            <a:ext cx="2971800" cy="458787"/>
+          </a:xfrm>
+          <a:prstGeom prst="rect">
+            <a:avLst/>
+          </a:prstGeom>
+        </p:spPr>
+        <p:txBody>
+          <a:bodyPr vert="horz" lIns="91440" tIns="45720" rIns="91440" bIns="45720" rtlCol="0" anchor="b"/>
+          <a:lstStyle>
+            <a:lvl1pPr algn="r">
+              <a:defRPr sz="1200"/>
+            </a:lvl1pPr>
+          </a:lstStyle>
+          <a:p>
+            <a:fld id="{8CADF99C-AF7E-4688-B727-7B33BD5CCDA3}" type="slidenum">
+              <a:rPr lang="en-US" smtClean="0"/>
+              <a:t>‹#›</a:t>
+            </a:fld>
+            <a:endParaRPr lang="en-US"/>
+          </a:p>
+        </p:txBody>
+      </p:sp>
+    </p:spTree>
+    <p:extLst>
+      <p:ext uri="{BB962C8B-B14F-4D97-AF65-F5344CB8AC3E}">
+        <p14:creationId xmlns:p14="http://schemas.microsoft.com/office/powerpoint/2010/main" val="2491075200"/>
+      </p:ext>
+    </p:extLst>
+  </p:cSld>
+  <p:clrMap bg1="lt1" tx1="dk1" bg2="lt2" tx2="dk2" accent1="accent1" accent2="accent2" accent3="accent3" accent4="accent4" accent5="accent5" accent6="accent6" hlink="hlink" folHlink="folHlink"/>
+  <p:notesStyle>
+    <a:lvl1pPr marL="0" algn="l" defTabSz="914400" rtl="0" eaLnBrk="1" latinLnBrk="0" hangingPunct="1">
+      <a:defRPr sz="1200" kern="1200">
+        <a:solidFill>
+          <a:schemeClr val="tx1"/>
+        </a:solidFill>
+        <a:latin typeface="+mn-lt"/>
+        <a:ea typeface="+mn-ea"/>
+        <a:cs typeface="+mn-cs"/>
+      </a:defRPr>
+    </a:lvl1pPr>
+    <a:lvl2pPr marL="457200" algn="l" defTabSz="914400" rtl="0" eaLnBrk="1" latinLnBrk="0" hangingPunct="1">
+      <a:defRPr sz="1200" kern="1200">
+        <a:solidFill>
+          <a:schemeClr val="tx1"/>
+        </a:solidFill>
+        <a:latin typeface="+mn-lt"/>
+        <a:ea typeface="+mn-ea"/>
+        <a:cs typeface="+mn-cs"/>
+      </a:defRPr>
+    </a:lvl2pPr>
+    <a:lvl3pPr marL="914400" algn="l" defTabSz="914400" rtl="0" eaLnBrk="1" latinLnBrk="0" hangingPunct="1">
+      <a:defRPr sz="1200" kern="1200">
+        <a:solidFill>
+          <a:schemeClr val="tx1"/>
+        </a:solidFill>
+        <a:latin typeface="+mn-lt"/>
+        <a:ea typeface="+mn-ea"/>
+        <a:cs typeface="+mn-cs"/>
+      </a:defRPr>
+    </a:lvl3pPr>
+    <a:lvl4pPr marL="1371600" algn="l" defTabSz="914400" rtl="0" eaLnBrk="1" latinLnBrk="0" hangingPunct="1">
+      <a:defRPr sz="1200" kern="1200">
+        <a:solidFill>
+          <a:schemeClr val="tx1"/>
+        </a:solidFill>
+        <a:latin typeface="+mn-lt"/>
+        <a:ea typeface="+mn-ea"/>
+        <a:cs typeface="+mn-cs"/>
+      </a:defRPr>
+    </a:lvl4pPr>
+    <a:lvl5pPr marL="1828800" algn="l" defTabSz="914400" rtl="0" eaLnBrk="1" latinLnBrk="0" hangingPunct="1">
+      <a:defRPr sz="1200" kern="1200">
+        <a:solidFill>
+          <a:schemeClr val="tx1"/>
+        </a:solidFill>
+        <a:latin typeface="+mn-lt"/>
+        <a:ea typeface="+mn-ea"/>
+        <a:cs typeface="+mn-cs"/>
+      </a:defRPr>
+    </a:lvl5pPr>
+    <a:lvl6pPr marL="2286000" algn="l" defTabSz="914400" rtl="0" eaLnBrk="1" latinLnBrk="0" hangingPunct="1">
+      <a:defRPr sz="1200" kern="1200">
+        <a:solidFill>
+          <a:schemeClr val="tx1"/>
+        </a:solidFill>
+        <a:latin typeface="+mn-lt"/>
+        <a:ea typeface="+mn-ea"/>
+        <a:cs typeface="+mn-cs"/>
+      </a:defRPr>
+    </a:lvl6pPr>
+    <a:lvl7pPr marL="2743200" algn="l" defTabSz="914400" rtl="0" eaLnBrk="1" latinLnBrk="0" hangingPunct="1">
+      <a:defRPr sz="1200" kern="1200">
+        <a:solidFill>
+          <a:schemeClr val="tx1"/>
+        </a:solidFill>
+        <a:latin typeface="+mn-lt"/>
+        <a:ea typeface="+mn-ea"/>
+        <a:cs typeface="+mn-cs"/>
+      </a:defRPr>
+    </a:lvl7pPr>
+    <a:lvl8pPr marL="3200400" algn="l" defTabSz="914400" rtl="0" eaLnBrk="1" latinLnBrk="0" hangingPunct="1">
+      <a:defRPr sz="1200" kern="1200">
+        <a:solidFill>
+          <a:schemeClr val="tx1"/>
+        </a:solidFill>
+        <a:latin typeface="+mn-lt"/>
+        <a:ea typeface="+mn-ea"/>
+        <a:cs typeface="+mn-cs"/>
+      </a:defRPr>
+    </a:lvl8pPr>
+    <a:lvl9pPr marL="3657600" algn="l" defTabSz="914400" rtl="0" eaLnBrk="1" latinLnBrk="0" hangingPunct="1">
+      <a:defRPr sz="1200" kern="1200">
+        <a:solidFill>
+          <a:schemeClr val="tx1"/>
+        </a:solidFill>
+        <a:latin typeface="+mn-lt"/>
+        <a:ea typeface="+mn-ea"/>
+        <a:cs typeface="+mn-cs"/>
+      </a:defRPr>
+    </a:lvl9pPr>
+  </p:notesStyle>
+</p:notesMaster>
+</file>
+
+<file path=ppt/notesSlides/notesSlide1.xml><?xml version="1.0" encoding="utf-8"?>
+<p:notes xmlns:a="http://schemas.openxmlformats.org/drawingml/2006/main" xmlns:r="http://schemas.openxmlformats.org/officeDocument/2006/relationships" xmlns:p="http://schemas.openxmlformats.org/presentationml/2006/main">
+  <p:cSld>
+    <p:spTree>
+      <p:nvGrpSpPr>
+        <p:cNvPr id="1" name=""/>
+        <p:cNvGrpSpPr/>
+        <p:nvPr/>
+      </p:nvGrpSpPr>
+      <p:grpSpPr>
+        <a:xfrm>
+          <a:off x="0" y="0"/>
+          <a:ext cx="0" cy="0"/>
+          <a:chOff x="0" y="0"/>
+          <a:chExt cx="0" cy="0"/>
+        </a:xfrm>
+      </p:grpSpPr>
+      <p:sp>
+        <p:nvSpPr>
+          <p:cNvPr id="2" name="Slide Image Placeholder 1"/>
+          <p:cNvSpPr>
+            <a:spLocks noGrp="1" noRot="1" noChangeAspect="1"/>
+          </p:cNvSpPr>
+          <p:nvPr>
+            <p:ph type="sldImg"/>
+          </p:nvPr>
+        </p:nvSpPr>
+        <p:spPr/>
+      </p:sp>
+      <p:sp>
+        <p:nvSpPr>
+          <p:cNvPr id="3" name="Notes Placeholder 2"/>
+          <p:cNvSpPr>
+            <a:spLocks noGrp="1"/>
+          </p:cNvSpPr>
+          <p:nvPr>
+            <p:ph type="body" idx="1"/>
+          </p:nvPr>
+        </p:nvSpPr>
+        <p:spPr/>
+        <p:txBody>
+          <a:bodyPr/>
+          <a:lstStyle/>
+          <a:p>
+            <a:pPr>
+              <a:buNone/>
+            </a:pPr>
+            <a:r>
+              <a:rPr lang="en-US" sz="2000" dirty="0"/>
+              <a:t>Les </a:t>
+            </a:r>
+            <a:r>
+              <a:rPr lang="en-US" sz="2000" dirty="0" err="1"/>
+              <a:t>établissements</a:t>
+            </a:r>
+            <a:r>
+              <a:rPr lang="en-US" sz="2000" dirty="0"/>
+              <a:t> de santé </a:t>
+            </a:r>
+            <a:r>
+              <a:rPr lang="en-US" sz="2000" dirty="0" err="1"/>
+              <a:t>gèrent</a:t>
+            </a:r>
+            <a:r>
+              <a:rPr lang="en-US" sz="2000" dirty="0"/>
+              <a:t> des </a:t>
+            </a:r>
+            <a:r>
+              <a:rPr lang="en-US" sz="2000" dirty="0" err="1"/>
+              <a:t>centaines</a:t>
+            </a:r>
+            <a:r>
+              <a:rPr lang="en-US" sz="2000" dirty="0"/>
+              <a:t> </a:t>
+            </a:r>
+            <a:r>
+              <a:rPr lang="en-US" sz="2000" dirty="0" err="1"/>
+              <a:t>voire</a:t>
+            </a:r>
+            <a:r>
+              <a:rPr lang="en-US" sz="2000" dirty="0"/>
+              <a:t> des </a:t>
+            </a:r>
+            <a:r>
+              <a:rPr lang="en-US" sz="2000" dirty="0" err="1"/>
+              <a:t>milliers</a:t>
+            </a:r>
+            <a:r>
+              <a:rPr lang="en-US" sz="2000" dirty="0"/>
+              <a:t> </a:t>
+            </a:r>
+            <a:r>
+              <a:rPr lang="en-US" sz="2000" dirty="0" err="1"/>
+              <a:t>d'employés</a:t>
+            </a:r>
+            <a:r>
+              <a:rPr lang="en-US" sz="2000" dirty="0"/>
+              <a:t>. La </a:t>
+            </a:r>
+            <a:r>
+              <a:rPr lang="en-US" sz="2000" dirty="0" err="1"/>
+              <a:t>création</a:t>
+            </a:r>
+            <a:r>
+              <a:rPr lang="en-US" sz="2000" dirty="0"/>
+              <a:t> </a:t>
+            </a:r>
+            <a:r>
+              <a:rPr lang="en-US" sz="2000" dirty="0" err="1"/>
+              <a:t>manuelle</a:t>
+            </a:r>
+            <a:r>
+              <a:rPr lang="en-US" sz="2000" dirty="0"/>
+              <a:t> des </a:t>
+            </a:r>
+            <a:r>
+              <a:rPr lang="en-US" sz="2000" dirty="0" err="1"/>
+              <a:t>comptes</a:t>
+            </a:r>
+            <a:r>
+              <a:rPr lang="en-US" sz="2000" dirty="0"/>
+              <a:t> </a:t>
+            </a:r>
+            <a:r>
+              <a:rPr lang="en-US" sz="2000" dirty="0" err="1"/>
+              <a:t>peut</a:t>
+            </a:r>
+            <a:r>
+              <a:rPr lang="en-US" sz="2000" dirty="0"/>
+              <a:t> </a:t>
+            </a:r>
+            <a:r>
+              <a:rPr lang="en-US" sz="2000" dirty="0" err="1"/>
+              <a:t>entraîner</a:t>
+            </a:r>
+            <a:r>
+              <a:rPr lang="en-US" sz="2000" dirty="0"/>
+              <a:t> des retards, des </a:t>
+            </a:r>
+            <a:r>
+              <a:rPr lang="en-US" sz="2000" dirty="0" err="1"/>
+              <a:t>erreurs</a:t>
+            </a:r>
+            <a:r>
+              <a:rPr lang="en-US" sz="2000" dirty="0"/>
+              <a:t> </a:t>
+            </a:r>
+            <a:r>
+              <a:rPr lang="en-US" sz="2000" dirty="0" err="1"/>
+              <a:t>ou</a:t>
+            </a:r>
+            <a:r>
+              <a:rPr lang="en-US" sz="2000" dirty="0"/>
+              <a:t> des </a:t>
+            </a:r>
+            <a:r>
+              <a:rPr lang="en-US" sz="2000" dirty="0" err="1"/>
+              <a:t>risques</a:t>
+            </a:r>
+            <a:r>
+              <a:rPr lang="en-US" sz="2000" dirty="0"/>
+              <a:t> de sécurité. Notre </a:t>
+            </a:r>
+            <a:r>
+              <a:rPr lang="en-US" sz="2000" dirty="0" err="1"/>
+              <a:t>objectif</a:t>
+            </a:r>
+            <a:r>
+              <a:rPr lang="en-US" sz="2000" dirty="0"/>
+              <a:t> est </a:t>
+            </a:r>
+            <a:r>
+              <a:rPr lang="en-US" sz="2000" dirty="0" err="1"/>
+              <a:t>d'automatiser</a:t>
+            </a:r>
+            <a:r>
+              <a:rPr lang="en-US" sz="2000" dirty="0"/>
+              <a:t> </a:t>
+            </a:r>
+            <a:r>
+              <a:rPr lang="en-US" sz="2000" dirty="0" err="1"/>
+              <a:t>ces</a:t>
+            </a:r>
+            <a:r>
+              <a:rPr lang="en-US" sz="2000" dirty="0"/>
+              <a:t> processus </a:t>
+            </a:r>
+            <a:r>
+              <a:rPr lang="en-US" sz="2000" dirty="0" err="1"/>
+              <a:t>afin</a:t>
+            </a:r>
+            <a:r>
+              <a:rPr lang="en-US" sz="2000" dirty="0"/>
+              <a:t> de </a:t>
+            </a:r>
+            <a:r>
+              <a:rPr lang="en-US" sz="2000" dirty="0" err="1"/>
+              <a:t>réduire</a:t>
+            </a:r>
+            <a:r>
+              <a:rPr lang="en-US" sz="2000" dirty="0"/>
+              <a:t> les </a:t>
+            </a:r>
+            <a:r>
+              <a:rPr lang="en-US" sz="2000" dirty="0" err="1"/>
+              <a:t>risques</a:t>
+            </a:r>
+            <a:r>
+              <a:rPr lang="en-US" sz="2000" dirty="0"/>
+              <a:t> et </a:t>
+            </a:r>
+            <a:r>
+              <a:rPr lang="en-US" sz="2000" dirty="0" err="1"/>
+              <a:t>améliorer</a:t>
+            </a:r>
+            <a:r>
+              <a:rPr lang="en-US" sz="2000" dirty="0"/>
+              <a:t> </a:t>
+            </a:r>
+            <a:r>
+              <a:rPr lang="en-US" sz="2000" dirty="0" err="1"/>
+              <a:t>l'efficacité</a:t>
+            </a:r>
+            <a:r>
+              <a:rPr lang="en-US" sz="2000" dirty="0"/>
+              <a:t> </a:t>
+            </a:r>
+            <a:r>
+              <a:rPr lang="en-US" sz="2000" dirty="0" err="1"/>
+              <a:t>opérationnelle</a:t>
+            </a:r>
+            <a:r>
+              <a:rPr lang="en-US" sz="2000" dirty="0"/>
+              <a:t>.</a:t>
+            </a:r>
+          </a:p>
+          <a:p>
+            <a:endParaRPr lang="en-US" dirty="0"/>
+          </a:p>
+        </p:txBody>
+      </p:sp>
+      <p:sp>
+        <p:nvSpPr>
+          <p:cNvPr id="4" name="Slide Number Placeholder 3"/>
+          <p:cNvSpPr>
+            <a:spLocks noGrp="1"/>
+          </p:cNvSpPr>
+          <p:nvPr>
+            <p:ph type="sldNum" sz="quarter" idx="5"/>
+          </p:nvPr>
+        </p:nvSpPr>
+        <p:spPr/>
+        <p:txBody>
+          <a:bodyPr/>
+          <a:lstStyle/>
+          <a:p>
+            <a:fld id="{8CADF99C-AF7E-4688-B727-7B33BD5CCDA3}" type="slidenum">
+              <a:rPr lang="en-US" smtClean="0"/>
+              <a:t>2</a:t>
+            </a:fld>
+            <a:endParaRPr lang="en-US"/>
+          </a:p>
+        </p:txBody>
+      </p:sp>
+    </p:spTree>
+    <p:extLst>
+      <p:ext uri="{BB962C8B-B14F-4D97-AF65-F5344CB8AC3E}">
+        <p14:creationId xmlns:p14="http://schemas.microsoft.com/office/powerpoint/2010/main" val="3422279232"/>
+      </p:ext>
+    </p:extLst>
+  </p:cSld>
+  <p:clrMapOvr>
+    <a:masterClrMapping/>
+  </p:clrMapOvr>
+</p:notes>
+</file>
+
+<file path=ppt/notesSlides/notesSlide2.xml><?xml version="1.0" encoding="utf-8"?>
+<p:notes xmlns:a="http://schemas.openxmlformats.org/drawingml/2006/main" xmlns:r="http://schemas.openxmlformats.org/officeDocument/2006/relationships" xmlns:p="http://schemas.openxmlformats.org/presentationml/2006/main">
+  <p:cSld>
+    <p:spTree>
+      <p:nvGrpSpPr>
+        <p:cNvPr id="1" name=""/>
+        <p:cNvGrpSpPr/>
+        <p:nvPr/>
+      </p:nvGrpSpPr>
+      <p:grpSpPr>
+        <a:xfrm>
+          <a:off x="0" y="0"/>
+          <a:ext cx="0" cy="0"/>
+          <a:chOff x="0" y="0"/>
+          <a:chExt cx="0" cy="0"/>
+        </a:xfrm>
+      </p:grpSpPr>
+      <p:sp>
+        <p:nvSpPr>
+          <p:cNvPr id="2" name="Slide Image Placeholder 1"/>
+          <p:cNvSpPr>
+            <a:spLocks noGrp="1" noRot="1" noChangeAspect="1"/>
+          </p:cNvSpPr>
+          <p:nvPr>
+            <p:ph type="sldImg"/>
+          </p:nvPr>
+        </p:nvSpPr>
+        <p:spPr/>
+      </p:sp>
+      <p:sp>
+        <p:nvSpPr>
+          <p:cNvPr id="3" name="Notes Placeholder 2"/>
+          <p:cNvSpPr>
+            <a:spLocks noGrp="1"/>
+          </p:cNvSpPr>
+          <p:nvPr>
+            <p:ph type="body" idx="1"/>
+          </p:nvPr>
+        </p:nvSpPr>
+        <p:spPr/>
+        <p:txBody>
+          <a:bodyPr/>
+          <a:lstStyle/>
+          <a:p>
+            <a:r>
+              <a:rPr lang="fr-FR" dirty="0"/>
+              <a:t>Lorsqu'un nouvel employé rejoint l'organisation, le système valide les données RH, vérifie les règles RBAC, crée le compte utilisateur, attribue les groupes nécessaires et enregistre toutes les actions dans les journaux d'audit.</a:t>
+            </a:r>
+            <a:endParaRPr lang="en-US" dirty="0"/>
+          </a:p>
+        </p:txBody>
+      </p:sp>
+      <p:sp>
+        <p:nvSpPr>
+          <p:cNvPr id="4" name="Slide Number Placeholder 3"/>
+          <p:cNvSpPr>
+            <a:spLocks noGrp="1"/>
+          </p:cNvSpPr>
+          <p:nvPr>
+            <p:ph type="sldNum" sz="quarter" idx="5"/>
+          </p:nvPr>
+        </p:nvSpPr>
+        <p:spPr/>
+        <p:txBody>
+          <a:bodyPr/>
+          <a:lstStyle/>
+          <a:p>
+            <a:fld id="{8CADF99C-AF7E-4688-B727-7B33BD5CCDA3}" type="slidenum">
+              <a:rPr lang="en-US" smtClean="0"/>
+              <a:t>5</a:t>
+            </a:fld>
+            <a:endParaRPr lang="en-US"/>
+          </a:p>
+        </p:txBody>
+      </p:sp>
+    </p:spTree>
+    <p:extLst>
+      <p:ext uri="{BB962C8B-B14F-4D97-AF65-F5344CB8AC3E}">
+        <p14:creationId xmlns:p14="http://schemas.microsoft.com/office/powerpoint/2010/main" val="4213608230"/>
+      </p:ext>
+    </p:extLst>
+  </p:cSld>
+  <p:clrMapOvr>
+    <a:masterClrMapping/>
+  </p:clrMapOvr>
+</p:notes>
+</file>
+
+<file path=ppt/notesSlides/notesSlide3.xml><?xml version="1.0" encoding="utf-8"?>
+<p:notes xmlns:a="http://schemas.openxmlformats.org/drawingml/2006/main" xmlns:r="http://schemas.openxmlformats.org/officeDocument/2006/relationships" xmlns:p="http://schemas.openxmlformats.org/presentationml/2006/main">
+  <p:cSld>
+    <p:spTree>
+      <p:nvGrpSpPr>
+        <p:cNvPr id="1" name=""/>
+        <p:cNvGrpSpPr/>
+        <p:nvPr/>
+      </p:nvGrpSpPr>
+      <p:grpSpPr>
+        <a:xfrm>
+          <a:off x="0" y="0"/>
+          <a:ext cx="0" cy="0"/>
+          <a:chOff x="0" y="0"/>
+          <a:chExt cx="0" cy="0"/>
+        </a:xfrm>
+      </p:grpSpPr>
+      <p:sp>
+        <p:nvSpPr>
+          <p:cNvPr id="2" name="Slide Image Placeholder 1"/>
+          <p:cNvSpPr>
+            <a:spLocks noGrp="1" noRot="1" noChangeAspect="1"/>
+          </p:cNvSpPr>
+          <p:nvPr>
+            <p:ph type="sldImg"/>
+          </p:nvPr>
+        </p:nvSpPr>
+        <p:spPr/>
+      </p:sp>
+      <p:sp>
+        <p:nvSpPr>
+          <p:cNvPr id="3" name="Notes Placeholder 2"/>
+          <p:cNvSpPr>
+            <a:spLocks noGrp="1"/>
+          </p:cNvSpPr>
+          <p:nvPr>
+            <p:ph type="body" idx="1"/>
+          </p:nvPr>
+        </p:nvSpPr>
+        <p:spPr/>
+        <p:txBody>
+          <a:bodyPr/>
+          <a:lstStyle/>
+          <a:p>
+            <a:r>
+              <a:rPr lang="en-US" dirty="0"/>
+              <a:t>Le </a:t>
+            </a:r>
+            <a:r>
+              <a:rPr lang="en-US" dirty="0" err="1"/>
+              <a:t>système</a:t>
+            </a:r>
+            <a:r>
+              <a:rPr lang="en-US" dirty="0"/>
+              <a:t> applique le </a:t>
+            </a:r>
+            <a:r>
+              <a:rPr lang="en-US" dirty="0" err="1"/>
+              <a:t>principe</a:t>
+            </a:r>
+            <a:r>
+              <a:rPr lang="en-US" dirty="0"/>
+              <a:t> du </a:t>
+            </a:r>
+            <a:r>
+              <a:rPr lang="en-US" dirty="0" err="1"/>
+              <a:t>moindre</a:t>
+            </a:r>
+            <a:r>
+              <a:rPr lang="en-US" dirty="0"/>
+              <a:t> </a:t>
+            </a:r>
+            <a:r>
+              <a:rPr lang="en-US" dirty="0" err="1"/>
+              <a:t>privilège</a:t>
+            </a:r>
+            <a:r>
+              <a:rPr lang="en-US" dirty="0"/>
+              <a:t>. Les </a:t>
+            </a:r>
+            <a:r>
+              <a:rPr lang="en-US" dirty="0" err="1"/>
+              <a:t>accès</a:t>
+            </a:r>
+            <a:r>
+              <a:rPr lang="en-US" dirty="0"/>
+              <a:t> </a:t>
+            </a:r>
+            <a:r>
+              <a:rPr lang="en-US" dirty="0" err="1"/>
+              <a:t>sont</a:t>
+            </a:r>
+            <a:r>
+              <a:rPr lang="en-US" dirty="0"/>
+              <a:t> </a:t>
+            </a:r>
+            <a:r>
+              <a:rPr lang="en-US" dirty="0" err="1"/>
+              <a:t>attribués</a:t>
+            </a:r>
+            <a:r>
+              <a:rPr lang="en-US" dirty="0"/>
+              <a:t> </a:t>
+            </a:r>
+            <a:r>
+              <a:rPr lang="en-US" dirty="0" err="1"/>
+              <a:t>automatiquement</a:t>
+            </a:r>
+            <a:r>
+              <a:rPr lang="en-US" dirty="0"/>
+              <a:t> </a:t>
+            </a:r>
+            <a:r>
+              <a:rPr lang="en-US" dirty="0" err="1"/>
+              <a:t>selon</a:t>
+            </a:r>
+            <a:r>
+              <a:rPr lang="en-US" dirty="0"/>
+              <a:t> le </a:t>
+            </a:r>
+            <a:r>
+              <a:rPr lang="en-US" dirty="0" err="1"/>
+              <a:t>rôle</a:t>
+            </a:r>
+            <a:r>
+              <a:rPr lang="en-US" dirty="0"/>
+              <a:t> de </a:t>
+            </a:r>
+            <a:r>
+              <a:rPr lang="en-US" dirty="0" err="1"/>
+              <a:t>l'employé</a:t>
+            </a:r>
+            <a:r>
+              <a:rPr lang="en-US" dirty="0"/>
+              <a:t> </a:t>
+            </a:r>
+            <a:r>
+              <a:rPr lang="en-US" dirty="0" err="1"/>
+              <a:t>afin</a:t>
+            </a:r>
+            <a:r>
+              <a:rPr lang="en-US" dirty="0"/>
+              <a:t> de limiter les </a:t>
+            </a:r>
+            <a:r>
+              <a:rPr lang="en-US" dirty="0" err="1"/>
+              <a:t>accès</a:t>
+            </a:r>
+            <a:r>
+              <a:rPr lang="en-US" dirty="0"/>
+              <a:t> </a:t>
+            </a:r>
+            <a:r>
+              <a:rPr lang="en-US" dirty="0" err="1"/>
+              <a:t>excessifs</a:t>
+            </a:r>
+            <a:r>
+              <a:rPr lang="en-US" dirty="0"/>
+              <a:t> et </a:t>
+            </a:r>
+            <a:r>
+              <a:rPr lang="en-US" dirty="0" err="1"/>
+              <a:t>renforcer</a:t>
+            </a:r>
+            <a:r>
+              <a:rPr lang="en-US" dirty="0"/>
+              <a:t> la sécurité.</a:t>
+            </a:r>
+          </a:p>
+        </p:txBody>
+      </p:sp>
+      <p:sp>
+        <p:nvSpPr>
+          <p:cNvPr id="4" name="Slide Number Placeholder 3"/>
+          <p:cNvSpPr>
+            <a:spLocks noGrp="1"/>
+          </p:cNvSpPr>
+          <p:nvPr>
+            <p:ph type="sldNum" sz="quarter" idx="5"/>
+          </p:nvPr>
+        </p:nvSpPr>
+        <p:spPr/>
+        <p:txBody>
+          <a:bodyPr/>
+          <a:lstStyle/>
+          <a:p>
+            <a:fld id="{8CADF99C-AF7E-4688-B727-7B33BD5CCDA3}" type="slidenum">
+              <a:rPr lang="en-US" smtClean="0"/>
+              <a:t>8</a:t>
+            </a:fld>
+            <a:endParaRPr lang="en-US"/>
+          </a:p>
+        </p:txBody>
+      </p:sp>
+    </p:spTree>
+    <p:extLst>
+      <p:ext uri="{BB962C8B-B14F-4D97-AF65-F5344CB8AC3E}">
+        <p14:creationId xmlns:p14="http://schemas.microsoft.com/office/powerpoint/2010/main" val="2516540216"/>
+      </p:ext>
+    </p:extLst>
+  </p:cSld>
+  <p:clrMapOvr>
+    <a:masterClrMapping/>
+  </p:clrMapOvr>
+</p:notes>
+</file>
+
+<file path=ppt/notesSlides/notesSlide4.xml><?xml version="1.0" encoding="utf-8"?>
+<p:notes xmlns:a="http://schemas.openxmlformats.org/drawingml/2006/main" xmlns:r="http://schemas.openxmlformats.org/officeDocument/2006/relationships" xmlns:p="http://schemas.openxmlformats.org/presentationml/2006/main">
+  <p:cSld>
+    <p:spTree>
+      <p:nvGrpSpPr>
+        <p:cNvPr id="1" name=""/>
+        <p:cNvGrpSpPr/>
+        <p:nvPr/>
+      </p:nvGrpSpPr>
+      <p:grpSpPr>
+        <a:xfrm>
+          <a:off x="0" y="0"/>
+          <a:ext cx="0" cy="0"/>
+          <a:chOff x="0" y="0"/>
+          <a:chExt cx="0" cy="0"/>
+        </a:xfrm>
+      </p:grpSpPr>
+      <p:sp>
+        <p:nvSpPr>
+          <p:cNvPr id="2" name="Slide Image Placeholder 1"/>
+          <p:cNvSpPr>
+            <a:spLocks noGrp="1" noRot="1" noChangeAspect="1"/>
+          </p:cNvSpPr>
+          <p:nvPr>
+            <p:ph type="sldImg"/>
+          </p:nvPr>
+        </p:nvSpPr>
+        <p:spPr/>
+      </p:sp>
+      <p:sp>
+        <p:nvSpPr>
+          <p:cNvPr id="3" name="Notes Placeholder 2"/>
+          <p:cNvSpPr>
+            <a:spLocks noGrp="1"/>
+          </p:cNvSpPr>
+          <p:nvPr>
+            <p:ph type="body" idx="1"/>
+          </p:nvPr>
+        </p:nvSpPr>
+        <p:spPr/>
+        <p:txBody>
+          <a:bodyPr/>
+          <a:lstStyle/>
+          <a:p>
+            <a:r>
+              <a:rPr lang="en-US" dirty="0"/>
+              <a:t>Avant toute </a:t>
+            </a:r>
+            <a:r>
+              <a:rPr lang="en-US" dirty="0" err="1"/>
+              <a:t>création</a:t>
+            </a:r>
+            <a:r>
+              <a:rPr lang="en-US" dirty="0"/>
+              <a:t> de compte, le </a:t>
+            </a:r>
+            <a:r>
+              <a:rPr lang="en-US" dirty="0" err="1"/>
+              <a:t>système</a:t>
+            </a:r>
+            <a:r>
+              <a:rPr lang="en-US" dirty="0"/>
+              <a:t> </a:t>
+            </a:r>
+            <a:r>
+              <a:rPr lang="en-US" dirty="0" err="1"/>
+              <a:t>vérifie</a:t>
+            </a:r>
+            <a:r>
+              <a:rPr lang="en-US" dirty="0"/>
+              <a:t> </a:t>
+            </a:r>
+            <a:r>
+              <a:rPr lang="en-US" dirty="0" err="1"/>
+              <a:t>que</a:t>
+            </a:r>
+            <a:r>
+              <a:rPr lang="en-US" dirty="0"/>
+              <a:t> les </a:t>
+            </a:r>
+            <a:r>
+              <a:rPr lang="en-US" dirty="0" err="1"/>
+              <a:t>informations</a:t>
+            </a:r>
+            <a:r>
+              <a:rPr lang="en-US" dirty="0"/>
+              <a:t> </a:t>
+            </a:r>
+            <a:r>
+              <a:rPr lang="en-US" dirty="0" err="1"/>
+              <a:t>essentielles</a:t>
+            </a:r>
+            <a:r>
+              <a:rPr lang="en-US" dirty="0"/>
+              <a:t> </a:t>
+            </a:r>
+            <a:r>
+              <a:rPr lang="en-US" dirty="0" err="1"/>
+              <a:t>sont</a:t>
+            </a:r>
+            <a:r>
+              <a:rPr lang="en-US" dirty="0"/>
+              <a:t> </a:t>
+            </a:r>
+            <a:r>
+              <a:rPr lang="en-US" dirty="0" err="1"/>
+              <a:t>présentes</a:t>
+            </a:r>
+            <a:r>
+              <a:rPr lang="en-US" dirty="0"/>
+              <a:t>. Si un </a:t>
+            </a:r>
+            <a:r>
+              <a:rPr lang="en-US" dirty="0" err="1"/>
+              <a:t>gestionnaire</a:t>
+            </a:r>
+            <a:r>
+              <a:rPr lang="en-US" dirty="0"/>
+              <a:t>, un département </a:t>
+            </a:r>
+            <a:r>
+              <a:rPr lang="en-US" dirty="0" err="1"/>
+              <a:t>ou</a:t>
+            </a:r>
+            <a:r>
+              <a:rPr lang="en-US" dirty="0"/>
+              <a:t> un </a:t>
+            </a:r>
+            <a:r>
+              <a:rPr lang="en-US" dirty="0" err="1"/>
+              <a:t>rôle</a:t>
+            </a:r>
+            <a:r>
+              <a:rPr lang="en-US" dirty="0"/>
+              <a:t> est </a:t>
+            </a:r>
+            <a:r>
+              <a:rPr lang="en-US" dirty="0" err="1"/>
+              <a:t>manquant</a:t>
+            </a:r>
+            <a:r>
+              <a:rPr lang="en-US" dirty="0"/>
+              <a:t>, le processus est </a:t>
+            </a:r>
+            <a:r>
+              <a:rPr lang="en-US" dirty="0" err="1"/>
+              <a:t>bloqué</a:t>
+            </a:r>
+            <a:r>
+              <a:rPr lang="en-US" dirty="0"/>
+              <a:t> </a:t>
+            </a:r>
+            <a:r>
+              <a:rPr lang="en-US" dirty="0" err="1"/>
+              <a:t>afin</a:t>
+            </a:r>
+            <a:r>
+              <a:rPr lang="en-US" dirty="0"/>
+              <a:t> </a:t>
+            </a:r>
+            <a:r>
+              <a:rPr lang="en-US" dirty="0" err="1"/>
+              <a:t>d'éviter</a:t>
+            </a:r>
+            <a:r>
+              <a:rPr lang="en-US" dirty="0"/>
+              <a:t> des </a:t>
+            </a:r>
+            <a:r>
+              <a:rPr lang="en-US" dirty="0" err="1"/>
+              <a:t>erreurs</a:t>
+            </a:r>
+            <a:r>
+              <a:rPr lang="en-US" dirty="0"/>
+              <a:t> de sécurité.</a:t>
+            </a:r>
+          </a:p>
+        </p:txBody>
+      </p:sp>
+      <p:sp>
+        <p:nvSpPr>
+          <p:cNvPr id="4" name="Slide Number Placeholder 3"/>
+          <p:cNvSpPr>
+            <a:spLocks noGrp="1"/>
+          </p:cNvSpPr>
+          <p:nvPr>
+            <p:ph type="sldNum" sz="quarter" idx="5"/>
+          </p:nvPr>
+        </p:nvSpPr>
+        <p:spPr/>
+        <p:txBody>
+          <a:bodyPr/>
+          <a:lstStyle/>
+          <a:p>
+            <a:fld id="{8CADF99C-AF7E-4688-B727-7B33BD5CCDA3}" type="slidenum">
+              <a:rPr lang="en-US" smtClean="0"/>
+              <a:t>9</a:t>
+            </a:fld>
+            <a:endParaRPr lang="en-US"/>
+          </a:p>
+        </p:txBody>
+      </p:sp>
+    </p:spTree>
+    <p:extLst>
+      <p:ext uri="{BB962C8B-B14F-4D97-AF65-F5344CB8AC3E}">
+        <p14:creationId xmlns:p14="http://schemas.microsoft.com/office/powerpoint/2010/main" val="4253024838"/>
+      </p:ext>
+    </p:extLst>
+  </p:cSld>
+  <p:clrMapOvr>
+    <a:masterClrMapping/>
+  </p:clrMapOvr>
+</p:notes>
+</file>
+
+<file path=ppt/notesSlides/notesSlide5.xml><?xml version="1.0" encoding="utf-8"?>
+<p:notes xmlns:a="http://schemas.openxmlformats.org/drawingml/2006/main" xmlns:r="http://schemas.openxmlformats.org/officeDocument/2006/relationships" xmlns:p="http://schemas.openxmlformats.org/presentationml/2006/main">
+  <p:cSld>
+    <p:spTree>
+      <p:nvGrpSpPr>
+        <p:cNvPr id="1" name=""/>
+        <p:cNvGrpSpPr/>
+        <p:nvPr/>
+      </p:nvGrpSpPr>
+      <p:grpSpPr>
+        <a:xfrm>
+          <a:off x="0" y="0"/>
+          <a:ext cx="0" cy="0"/>
+          <a:chOff x="0" y="0"/>
+          <a:chExt cx="0" cy="0"/>
+        </a:xfrm>
+      </p:grpSpPr>
+      <p:sp>
+        <p:nvSpPr>
+          <p:cNvPr id="2" name="Slide Image Placeholder 1"/>
+          <p:cNvSpPr>
+            <a:spLocks noGrp="1" noRot="1" noChangeAspect="1"/>
+          </p:cNvSpPr>
+          <p:nvPr>
+            <p:ph type="sldImg"/>
+          </p:nvPr>
+        </p:nvSpPr>
+        <p:spPr/>
+      </p:sp>
+      <p:sp>
+        <p:nvSpPr>
+          <p:cNvPr id="3" name="Notes Placeholder 2"/>
+          <p:cNvSpPr>
+            <a:spLocks noGrp="1"/>
+          </p:cNvSpPr>
+          <p:nvPr>
+            <p:ph type="body" idx="1"/>
+          </p:nvPr>
+        </p:nvSpPr>
+        <p:spPr/>
+        <p:txBody>
+          <a:bodyPr/>
+          <a:lstStyle/>
+          <a:p>
+            <a:r>
+              <a:rPr lang="en-US" dirty="0"/>
+              <a:t>Cette architecture </a:t>
+            </a:r>
+            <a:r>
+              <a:rPr lang="en-US" dirty="0" err="1"/>
+              <a:t>représente</a:t>
+            </a:r>
+            <a:r>
+              <a:rPr lang="en-US" dirty="0"/>
+              <a:t> </a:t>
+            </a:r>
+            <a:r>
+              <a:rPr lang="en-US" dirty="0" err="1"/>
+              <a:t>l'évolution</a:t>
+            </a:r>
+            <a:r>
+              <a:rPr lang="en-US" dirty="0"/>
+              <a:t> du MVP vers </a:t>
+            </a:r>
+            <a:r>
+              <a:rPr lang="en-US" dirty="0" err="1"/>
+              <a:t>une</a:t>
+            </a:r>
+            <a:r>
+              <a:rPr lang="en-US" dirty="0"/>
+              <a:t> solution </a:t>
+            </a:r>
+            <a:r>
+              <a:rPr lang="en-US" dirty="0" err="1"/>
+              <a:t>d'entreprise</a:t>
+            </a:r>
+            <a:r>
+              <a:rPr lang="en-US" dirty="0"/>
+              <a:t> </a:t>
+            </a:r>
+            <a:r>
+              <a:rPr lang="en-US" dirty="0" err="1"/>
+              <a:t>intégrant</a:t>
+            </a:r>
+            <a:r>
+              <a:rPr lang="en-US" dirty="0"/>
+              <a:t> Active Directory, Microsoft Entra ID, Microsoft 365, les </a:t>
+            </a:r>
+            <a:r>
+              <a:rPr lang="en-US" dirty="0" err="1"/>
+              <a:t>systèmes</a:t>
+            </a:r>
+            <a:r>
+              <a:rPr lang="en-US" dirty="0"/>
+              <a:t> RH et les </a:t>
+            </a:r>
+            <a:r>
+              <a:rPr lang="en-US" dirty="0" err="1"/>
+              <a:t>outils</a:t>
+            </a:r>
+            <a:r>
+              <a:rPr lang="en-US" dirty="0"/>
+              <a:t> ITSM.</a:t>
+            </a:r>
+          </a:p>
+        </p:txBody>
+      </p:sp>
+      <p:sp>
+        <p:nvSpPr>
+          <p:cNvPr id="4" name="Slide Number Placeholder 3"/>
+          <p:cNvSpPr>
+            <a:spLocks noGrp="1"/>
+          </p:cNvSpPr>
+          <p:nvPr>
+            <p:ph type="sldNum" sz="quarter" idx="5"/>
+          </p:nvPr>
+        </p:nvSpPr>
+        <p:spPr/>
+        <p:txBody>
+          <a:bodyPr/>
+          <a:lstStyle/>
+          <a:p>
+            <a:fld id="{8CADF99C-AF7E-4688-B727-7B33BD5CCDA3}" type="slidenum">
+              <a:rPr lang="en-US" smtClean="0"/>
+              <a:t>11</a:t>
+            </a:fld>
+            <a:endParaRPr lang="en-US"/>
+          </a:p>
+        </p:txBody>
+      </p:sp>
+    </p:spTree>
+    <p:extLst>
+      <p:ext uri="{BB962C8B-B14F-4D97-AF65-F5344CB8AC3E}">
+        <p14:creationId xmlns:p14="http://schemas.microsoft.com/office/powerpoint/2010/main" val="2736463003"/>
+      </p:ext>
+    </p:extLst>
+  </p:cSld>
+  <p:clrMapOvr>
+    <a:masterClrMapping/>
+  </p:clrMapOvr>
+</p:notes>
 </file>
 
 <file path=ppt/slideLayouts/slideLayout1.xml><?xml version="1.0" encoding="utf-8"?>
@@ -3894,7 +5176,7 @@
           <a:lstStyle/>
           <a:p>
             <a:pPr algn="l"/>
-            <a:endParaRPr lang="en-US" sz="2000">
+            <a:endParaRPr lang="en-US" sz="2000" dirty="0">
               <a:solidFill>
                 <a:srgbClr val="FFFFFF"/>
               </a:solidFill>
@@ -4612,7 +5894,7 @@
           <p:nvPr/>
         </p:nvPicPr>
         <p:blipFill>
-          <a:blip r:embed="rId2"/>
+          <a:blip r:embed="rId3"/>
           <a:stretch>
             <a:fillRect/>
           </a:stretch>
@@ -7780,7 +9062,7 @@
           <p:nvPr/>
         </p:nvPicPr>
         <p:blipFill>
-          <a:blip r:embed="rId2"/>
+          <a:blip r:embed="rId3"/>
           <a:stretch>
             <a:fillRect/>
           </a:stretch>
@@ -11311,7 +12593,7 @@
           <p:nvPr/>
         </p:nvPicPr>
         <p:blipFill>
-          <a:blip r:embed="rId2"/>
+          <a:blip r:embed="rId3"/>
           <a:stretch>
             <a:fillRect/>
           </a:stretch>
@@ -11652,4 +12934,319 @@
     </a:ext>
   </a:extLst>
 </a:theme>
+</file>
+
+<file path=ppt/theme/theme2.xml><?xml version="1.0" encoding="utf-8"?>
+<a:theme xmlns:a="http://schemas.openxmlformats.org/drawingml/2006/main" name="Office Theme">
+  <a:themeElements>
+    <a:clrScheme name="Office">
+      <a:dk1>
+        <a:sysClr val="windowText" lastClr="000000"/>
+      </a:dk1>
+      <a:lt1>
+        <a:sysClr val="window" lastClr="FFFFFF"/>
+      </a:lt1>
+      <a:dk2>
+        <a:srgbClr val="0E2841"/>
+      </a:dk2>
+      <a:lt2>
+        <a:srgbClr val="E8E8E8"/>
+      </a:lt2>
+      <a:accent1>
+        <a:srgbClr val="156082"/>
+      </a:accent1>
+      <a:accent2>
+        <a:srgbClr val="E97132"/>
+      </a:accent2>
+      <a:accent3>
+        <a:srgbClr val="196B24"/>
+      </a:accent3>
+      <a:accent4>
+        <a:srgbClr val="0F9ED5"/>
+      </a:accent4>
+      <a:accent5>
+        <a:srgbClr val="A02B93"/>
+      </a:accent5>
+      <a:accent6>
+        <a:srgbClr val="4EA72E"/>
+      </a:accent6>
+      <a:hlink>
+        <a:srgbClr val="467886"/>
+      </a:hlink>
+      <a:folHlink>
+        <a:srgbClr val="96607D"/>
+      </a:folHlink>
+    </a:clrScheme>
+    <a:fontScheme name="Office">
+      <a:majorFont>
+        <a:latin typeface="Aptos Display" panose="02110004020202020204"/>
+        <a:ea typeface=""/>
+        <a:cs typeface=""/>
+        <a:font script="Jpan" typeface="游ゴシック Light"/>
+        <a:font script="Hang" typeface="맑은 고딕"/>
+        <a:font script="Hans" typeface="等线 Light"/>
+        <a:font script="Hant" typeface="新細明體"/>
+        <a:font script="Arab" typeface="Times New Roman"/>
+        <a:font script="Hebr" typeface="Times New Roman"/>
+        <a:font script="Thai" typeface="Angsana New"/>
+        <a:font script="Ethi" typeface="Nyala"/>
+        <a:font script="Beng" typeface="Vrinda"/>
+        <a:font script="Gujr" typeface="Shruti"/>
+        <a:font script="Khmr" typeface="MoolBoran"/>
+        <a:font script="Knda" typeface="Tunga"/>
+        <a:font script="Guru" typeface="Raavi"/>
+        <a:font script="Cans" typeface="Euphemia"/>
+        <a:font script="Cher" typeface="Plantagenet Cherokee"/>
+        <a:font script="Yiii" typeface="Microsoft Yi Baiti"/>
+        <a:font script="Tibt" typeface="Microsoft Himalaya"/>
+        <a:font script="Thaa" typeface="MV Boli"/>
+        <a:font script="Deva" typeface="Mangal"/>
+        <a:font script="Telu" typeface="Gautami"/>
+        <a:font script="Taml" typeface="Latha"/>
+        <a:font script="Syrc" typeface="Estrangelo Edessa"/>
+        <a:font script="Orya" typeface="Kalinga"/>
+        <a:font script="Mlym" typeface="Kartika"/>
+        <a:font script="Laoo" typeface="DokChampa"/>
+        <a:font script="Sinh" typeface="Iskoola Pota"/>
+        <a:font script="Mong" typeface="Mongolian Baiti"/>
+        <a:font script="Viet" typeface="Times New Roman"/>
+        <a:font script="Uigh" typeface="Microsoft Uighur"/>
+        <a:font script="Geor" typeface="Sylfaen"/>
+        <a:font script="Armn" typeface="Arial"/>
+        <a:font script="Bugi" typeface="Leelawadee UI"/>
+        <a:font script="Bopo" typeface="Microsoft JhengHei"/>
+        <a:font script="Java" typeface="Javanese Text"/>
+        <a:font script="Lisu" typeface="Segoe UI"/>
+        <a:font script="Mymr" typeface="Myanmar Text"/>
+        <a:font script="Nkoo" typeface="Ebrima"/>
+        <a:font script="Olck" typeface="Nirmala UI"/>
+        <a:font script="Osma" typeface="Ebrima"/>
+        <a:font script="Phag" typeface="Phagspa"/>
+        <a:font script="Syrn" typeface="Estrangelo Edessa"/>
+        <a:font script="Syrj" typeface="Estrangelo Edessa"/>
+        <a:font script="Syre" typeface="Estrangelo Edessa"/>
+        <a:font script="Sora" typeface="Nirmala UI"/>
+        <a:font script="Tale" typeface="Microsoft Tai Le"/>
+        <a:font script="Talu" typeface="Microsoft New Tai Lue"/>
+        <a:font script="Tfng" typeface="Ebrima"/>
+      </a:majorFont>
+      <a:minorFont>
+        <a:latin typeface="Aptos" panose="02110004020202020204"/>
+        <a:ea typeface=""/>
+        <a:cs typeface=""/>
+        <a:font script="Jpan" typeface="游ゴシック"/>
+        <a:font script="Hang" typeface="맑은 고딕"/>
+        <a:font script="Hans" typeface="等线"/>
+        <a:font script="Hant" typeface="新細明體"/>
+        <a:font script="Arab" typeface="Arial"/>
+        <a:font script="Hebr" typeface="Arial"/>
+        <a:font script="Thai" typeface="Cordia New"/>
+        <a:font script="Ethi" typeface="Nyala"/>
+        <a:font script="Beng" typeface="Vrinda"/>
+        <a:font script="Gujr" typeface="Shruti"/>
+        <a:font script="Khmr" typeface="DaunPenh"/>
+        <a:font script="Knda" typeface="Tunga"/>
+        <a:font script="Guru" typeface="Raavi"/>
+        <a:font script="Cans" typeface="Euphemia"/>
+        <a:font script="Cher" typeface="Plantagenet Cherokee"/>
+        <a:font script="Yiii" typeface="Microsoft Yi Baiti"/>
+        <a:font script="Tibt" typeface="Microsoft Himalaya"/>
+        <a:font script="Thaa" typeface="MV Boli"/>
+        <a:font script="Deva" typeface="Mangal"/>
+        <a:font script="Telu" typeface="Gautami"/>
+        <a:font script="Taml" typeface="Latha"/>
+        <a:font script="Syrc" typeface="Estrangelo Edessa"/>
+        <a:font script="Orya" typeface="Kalinga"/>
+        <a:font script="Mlym" typeface="Kartika"/>
+        <a:font script="Laoo" typeface="DokChampa"/>
+        <a:font script="Sinh" typeface="Iskoola Pota"/>
+        <a:font script="Mong" typeface="Mongolian Baiti"/>
+        <a:font script="Viet" typeface="Arial"/>
+        <a:font script="Uigh" typeface="Microsoft Uighur"/>
+        <a:font script="Geor" typeface="Sylfaen"/>
+        <a:font script="Armn" typeface="Arial"/>
+        <a:font script="Bugi" typeface="Leelawadee UI"/>
+        <a:font script="Bopo" typeface="Microsoft JhengHei"/>
+        <a:font script="Java" typeface="Javanese Text"/>
+        <a:font script="Lisu" typeface="Segoe UI"/>
+        <a:font script="Mymr" typeface="Myanmar Text"/>
+        <a:font script="Nkoo" typeface="Ebrima"/>
+        <a:font script="Olck" typeface="Nirmala UI"/>
+        <a:font script="Osma" typeface="Ebrima"/>
+        <a:font script="Phag" typeface="Phagspa"/>
+        <a:font script="Syrn" typeface="Estrangelo Edessa"/>
+        <a:font script="Syrj" typeface="Estrangelo Edessa"/>
+        <a:font script="Syre" typeface="Estrangelo Edessa"/>
+        <a:font script="Sora" typeface="Nirmala UI"/>
+        <a:font script="Tale" typeface="Microsoft Tai Le"/>
+        <a:font script="Talu" typeface="Microsoft New Tai Lue"/>
+        <a:font script="Tfng" typeface="Ebrima"/>
+      </a:minorFont>
+    </a:fontScheme>
+    <a:fmtScheme name="Office">
+      <a:fillStyleLst>
+        <a:solidFill>
+          <a:schemeClr val="phClr"/>
+        </a:solidFill>
+        <a:gradFill rotWithShape="1">
+          <a:gsLst>
+            <a:gs pos="0">
+              <a:schemeClr val="phClr">
+                <a:lumMod val="110000"/>
+                <a:satMod val="105000"/>
+                <a:tint val="67000"/>
+              </a:schemeClr>
+            </a:gs>
+            <a:gs pos="50000">
+              <a:schemeClr val="phClr">
+                <a:lumMod val="105000"/>
+                <a:satMod val="103000"/>
+                <a:tint val="73000"/>
+              </a:schemeClr>
+            </a:gs>
+            <a:gs pos="100000">
+              <a:schemeClr val="phClr">
+                <a:lumMod val="105000"/>
+                <a:satMod val="109000"/>
+                <a:tint val="81000"/>
+              </a:schemeClr>
+            </a:gs>
+          </a:gsLst>
+          <a:lin ang="5400000" scaled="0"/>
+        </a:gradFill>
+        <a:gradFill rotWithShape="1">
+          <a:gsLst>
+            <a:gs pos="0">
+              <a:schemeClr val="phClr">
+                <a:satMod val="103000"/>
+                <a:lumMod val="102000"/>
+                <a:tint val="94000"/>
+              </a:schemeClr>
+            </a:gs>
+            <a:gs pos="50000">
+              <a:schemeClr val="phClr">
+                <a:satMod val="110000"/>
+                <a:lumMod val="100000"/>
+                <a:shade val="100000"/>
+              </a:schemeClr>
+            </a:gs>
+            <a:gs pos="100000">
+              <a:schemeClr val="phClr">
+                <a:lumMod val="99000"/>
+                <a:satMod val="120000"/>
+                <a:shade val="78000"/>
+              </a:schemeClr>
+            </a:gs>
+          </a:gsLst>
+          <a:lin ang="5400000" scaled="0"/>
+        </a:gradFill>
+      </a:fillStyleLst>
+      <a:lnStyleLst>
+        <a:ln w="12700" cap="flat" cmpd="sng" algn="ctr">
+          <a:solidFill>
+            <a:schemeClr val="phClr"/>
+          </a:solidFill>
+          <a:prstDash val="solid"/>
+          <a:miter lim="800000"/>
+        </a:ln>
+        <a:ln w="19050" cap="flat" cmpd="sng" algn="ctr">
+          <a:solidFill>
+            <a:schemeClr val="phClr"/>
+          </a:solidFill>
+          <a:prstDash val="solid"/>
+          <a:miter lim="800000"/>
+        </a:ln>
+        <a:ln w="25400" cap="flat" cmpd="sng" algn="ctr">
+          <a:solidFill>
+            <a:schemeClr val="phClr"/>
+          </a:solidFill>
+          <a:prstDash val="solid"/>
+          <a:miter lim="800000"/>
+        </a:ln>
+      </a:lnStyleLst>
+      <a:effectStyleLst>
+        <a:effectStyle>
+          <a:effectLst/>
+        </a:effectStyle>
+        <a:effectStyle>
+          <a:effectLst/>
+        </a:effectStyle>
+        <a:effectStyle>
+          <a:effectLst>
+            <a:outerShdw blurRad="57150" dist="19050" dir="5400000" algn="ctr" rotWithShape="0">
+              <a:srgbClr val="000000">
+                <a:alpha val="63000"/>
+              </a:srgbClr>
+            </a:outerShdw>
+          </a:effectLst>
+        </a:effectStyle>
+      </a:effectStyleLst>
+      <a:bgFillStyleLst>
+        <a:solidFill>
+          <a:schemeClr val="phClr"/>
+        </a:solidFill>
+        <a:solidFill>
+          <a:schemeClr val="phClr">
+            <a:tint val="95000"/>
+            <a:satMod val="170000"/>
+          </a:schemeClr>
+        </a:solidFill>
+        <a:gradFill rotWithShape="1">
+          <a:gsLst>
+            <a:gs pos="0">
+              <a:schemeClr val="phClr">
+                <a:tint val="93000"/>
+                <a:satMod val="150000"/>
+                <a:shade val="98000"/>
+                <a:lumMod val="102000"/>
+              </a:schemeClr>
+            </a:gs>
+            <a:gs pos="50000">
+              <a:schemeClr val="phClr">
+                <a:tint val="98000"/>
+                <a:satMod val="130000"/>
+                <a:shade val="90000"/>
+                <a:lumMod val="103000"/>
+              </a:schemeClr>
+            </a:gs>
+            <a:gs pos="100000">
+              <a:schemeClr val="phClr">
+                <a:shade val="63000"/>
+                <a:satMod val="120000"/>
+              </a:schemeClr>
+            </a:gs>
+          </a:gsLst>
+          <a:lin ang="5400000" scaled="0"/>
+        </a:gradFill>
+      </a:bgFillStyleLst>
+    </a:fmtScheme>
+  </a:themeElements>
+  <a:objectDefaults>
+    <a:lnDef>
+      <a:spPr/>
+      <a:bodyPr/>
+      <a:lstStyle/>
+      <a:style>
+        <a:lnRef idx="2">
+          <a:schemeClr val="accent1"/>
+        </a:lnRef>
+        <a:fillRef idx="0">
+          <a:schemeClr val="accent1"/>
+        </a:fillRef>
+        <a:effectRef idx="1">
+          <a:schemeClr val="accent1"/>
+        </a:effectRef>
+        <a:fontRef idx="minor">
+          <a:schemeClr val="tx1"/>
+        </a:fontRef>
+      </a:style>
+    </a:lnDef>
+  </a:objectDefaults>
+  <a:extraClrSchemeLst/>
+  <a:extLst>
+    <a:ext uri="{05A4C25C-085E-4340-85A3-A5531E510DB2}">
+      <thm15:themeFamily xmlns:thm15="http://schemas.microsoft.com/office/thememl/2012/main" name="Office Theme" id="{2E142A2C-CD16-42D6-873A-C26D2A0506FA}" vid="{1BDDFF52-6CD6-40A5-AB3C-68EB2F1E4D0A}"/>
+    </a:ext>
+  </a:extLst>
+</a:theme>
 </file>
</xml_diff>

<commit_message>
updated Healthcare IAM Lifecycle Automation
</commit_message>
<xml_diff>
--- a/09-Presentation/IAM-Healthcare-Automation-Professional.pptx
+++ b/09-Presentation/IAM-Healthcare-Automation-Professional.pptx
@@ -520,200 +520,204 @@
           <a:bodyPr/>
           <a:lstStyle/>
           <a:p>
-            <a:pPr>
-              <a:buNone/>
-            </a:pPr>
-            <a:r>
-              <a:rPr lang="en-US" sz="2000" dirty="0"/>
-              <a:t>Les </a:t>
-            </a:r>
-            <a:r>
-              <a:rPr lang="en-US" sz="2000" dirty="0" err="1"/>
+            <a:r>
+              <a:rPr lang="en-US" dirty="0"/>
+              <a:t>Le </a:t>
+            </a:r>
+            <a:r>
+              <a:rPr lang="en-US" dirty="0" err="1"/>
+              <a:t>projet</a:t>
+            </a:r>
+            <a:r>
+              <a:rPr lang="en-US" dirty="0"/>
+              <a:t> </a:t>
+            </a:r>
+            <a:r>
+              <a:rPr lang="en-US" dirty="0" err="1"/>
+              <a:t>répond</a:t>
+            </a:r>
+            <a:r>
+              <a:rPr lang="en-US" dirty="0"/>
+              <a:t> à un </a:t>
+            </a:r>
+            <a:r>
+              <a:rPr lang="en-US" dirty="0" err="1"/>
+              <a:t>problème</a:t>
+            </a:r>
+            <a:r>
+              <a:rPr lang="en-US" dirty="0"/>
+              <a:t> </a:t>
+            </a:r>
+            <a:r>
+              <a:rPr lang="en-US" dirty="0" err="1"/>
+              <a:t>fréquent</a:t>
+            </a:r>
+            <a:r>
+              <a:rPr lang="en-US" dirty="0"/>
+              <a:t> dans les </a:t>
+            </a:r>
+            <a:r>
+              <a:rPr lang="en-US" dirty="0" err="1"/>
               <a:t>établissements</a:t>
             </a:r>
             <a:r>
-              <a:rPr lang="en-US" sz="2000" dirty="0"/>
-              <a:t> de santé </a:t>
-            </a:r>
-            <a:r>
-              <a:rPr lang="en-US" sz="2000" dirty="0" err="1"/>
-              <a:t>gèrent</a:t>
-            </a:r>
-            <a:r>
-              <a:rPr lang="en-US" sz="2000" dirty="0"/>
+              <a:rPr lang="en-US" dirty="0"/>
+              <a:t> de santé : la gestion du cycle de vie des </a:t>
+            </a:r>
+            <a:r>
+              <a:rPr lang="en-US" dirty="0" err="1"/>
+              <a:t>employés</a:t>
+            </a:r>
+            <a:r>
+              <a:rPr lang="en-US" dirty="0"/>
+              <a:t> et des </a:t>
+            </a:r>
+            <a:r>
+              <a:rPr lang="en-US" dirty="0" err="1"/>
+              <a:t>accès</a:t>
+            </a:r>
+            <a:r>
+              <a:rPr lang="en-US" dirty="0"/>
+              <a:t> </a:t>
+            </a:r>
+            <a:r>
+              <a:rPr lang="en-US" dirty="0" err="1"/>
+              <a:t>associés</a:t>
+            </a:r>
+            <a:r>
+              <a:rPr lang="en-US" dirty="0"/>
+              <a:t>. </a:t>
+            </a:r>
+            <a:r>
+              <a:rPr lang="en-US" dirty="0" err="1"/>
+              <a:t>L'objectif</a:t>
+            </a:r>
+            <a:r>
+              <a:rPr lang="en-US" dirty="0"/>
+              <a:t> est </a:t>
+            </a:r>
+            <a:r>
+              <a:rPr lang="en-US" dirty="0" err="1"/>
+              <a:t>d'automatiser</a:t>
+            </a:r>
+            <a:r>
+              <a:rPr lang="en-US" dirty="0"/>
+              <a:t> </a:t>
+            </a:r>
+            <a:r>
+              <a:rPr lang="en-US" dirty="0" err="1"/>
+              <a:t>l'arrivée</a:t>
+            </a:r>
+            <a:r>
+              <a:rPr lang="en-US" dirty="0"/>
+              <a:t>, les changements de poste et le </a:t>
+            </a:r>
+            <a:r>
+              <a:rPr lang="en-US" dirty="0" err="1"/>
+              <a:t>départ</a:t>
+            </a:r>
+            <a:r>
+              <a:rPr lang="en-US" dirty="0"/>
               <a:t> des </a:t>
             </a:r>
             <a:r>
-              <a:rPr lang="en-US" sz="2000" dirty="0" err="1"/>
-              <a:t>centaines</a:t>
-            </a:r>
-            <a:r>
-              <a:rPr lang="en-US" sz="2000" dirty="0"/>
+              <a:rPr lang="en-US" dirty="0" err="1"/>
+              <a:t>employés</a:t>
+            </a:r>
+            <a:r>
+              <a:rPr lang="en-US" dirty="0"/>
+              <a:t> tout </a:t>
+            </a:r>
+            <a:r>
+              <a:rPr lang="en-US" dirty="0" err="1"/>
+              <a:t>en</a:t>
+            </a:r>
+            <a:r>
+              <a:rPr lang="en-US" dirty="0"/>
               <a:t> </a:t>
             </a:r>
             <a:r>
-              <a:rPr lang="en-US" sz="2000" dirty="0" err="1"/>
-              <a:t>voire</a:t>
-            </a:r>
-            <a:r>
-              <a:rPr lang="en-US" sz="2000" dirty="0"/>
-              <a:t> des </a:t>
-            </a:r>
-            <a:r>
-              <a:rPr lang="en-US" sz="2000" dirty="0" err="1"/>
-              <a:t>milliers</a:t>
-            </a:r>
-            <a:r>
-              <a:rPr lang="en-US" sz="2000" dirty="0"/>
+              <a:rPr lang="en-US" dirty="0" err="1"/>
+              <a:t>appliquant</a:t>
+            </a:r>
+            <a:r>
+              <a:rPr lang="en-US" dirty="0"/>
+              <a:t> les principes de sécurité, de </a:t>
+            </a:r>
+            <a:r>
+              <a:rPr lang="en-US" dirty="0" err="1"/>
+              <a:t>gouvernance</a:t>
+            </a:r>
+            <a:r>
+              <a:rPr lang="en-US" dirty="0"/>
+              <a:t> et de </a:t>
+            </a:r>
+            <a:r>
+              <a:rPr lang="en-US" dirty="0" err="1"/>
+              <a:t>traçabilité</a:t>
+            </a:r>
+            <a:r>
+              <a:rPr lang="en-US" dirty="0"/>
+              <a:t>.</a:t>
+            </a:r>
+            <a:br>
+              <a:rPr lang="en-US" dirty="0"/>
+            </a:br>
+            <a:br>
+              <a:rPr lang="en-US" dirty="0"/>
+            </a:br>
+            <a:r>
+              <a:rPr lang="en-US" dirty="0"/>
+              <a:t>Pour </a:t>
+            </a:r>
+            <a:r>
+              <a:rPr lang="en-US" dirty="0" err="1"/>
+              <a:t>réaliser</a:t>
+            </a:r>
+            <a:r>
+              <a:rPr lang="en-US" dirty="0"/>
               <a:t> </a:t>
             </a:r>
             <a:r>
-              <a:rPr lang="en-US" sz="2000" dirty="0" err="1"/>
-              <a:t>d'employés</a:t>
-            </a:r>
-            <a:r>
-              <a:rPr lang="en-US" sz="2000" dirty="0"/>
-              <a:t>. La </a:t>
-            </a:r>
-            <a:r>
-              <a:rPr lang="en-US" sz="2000" dirty="0" err="1"/>
-              <a:t>création</a:t>
-            </a:r>
-            <a:r>
-              <a:rPr lang="en-US" sz="2000" dirty="0"/>
+              <a:rPr lang="en-US" dirty="0" err="1"/>
+              <a:t>cette</a:t>
+            </a:r>
+            <a:r>
+              <a:rPr lang="en-US" dirty="0"/>
               <a:t> </a:t>
             </a:r>
             <a:r>
-              <a:rPr lang="en-US" sz="2000" dirty="0" err="1"/>
-              <a:t>manuelle</a:t>
-            </a:r>
-            <a:r>
-              <a:rPr lang="en-US" sz="2000" dirty="0"/>
-              <a:t> des </a:t>
-            </a:r>
-            <a:r>
-              <a:rPr lang="en-US" sz="2000" dirty="0" err="1"/>
-              <a:t>comptes</a:t>
-            </a:r>
-            <a:r>
-              <a:rPr lang="en-US" sz="2000" dirty="0"/>
+              <a:rPr lang="en-US" dirty="0" err="1"/>
+              <a:t>preuve</a:t>
+            </a:r>
+            <a:r>
+              <a:rPr lang="en-US" dirty="0"/>
+              <a:t> de concept, </a:t>
+            </a:r>
+            <a:r>
+              <a:rPr lang="en-US" dirty="0" err="1"/>
+              <a:t>j'ai</a:t>
+            </a:r>
+            <a:r>
+              <a:rPr lang="en-US" dirty="0"/>
               <a:t> </a:t>
             </a:r>
             <a:r>
-              <a:rPr lang="en-US" sz="2000" dirty="0" err="1"/>
-              <a:t>peut</a:t>
-            </a:r>
-            <a:r>
-              <a:rPr lang="en-US" sz="2000" dirty="0"/>
-              <a:t> </a:t>
-            </a:r>
-            <a:r>
-              <a:rPr lang="en-US" sz="2000" dirty="0" err="1"/>
-              <a:t>entraîner</a:t>
-            </a:r>
-            <a:r>
-              <a:rPr lang="en-US" sz="2000" dirty="0"/>
-              <a:t> des retards, des </a:t>
-            </a:r>
-            <a:r>
-              <a:rPr lang="en-US" sz="2000" dirty="0" err="1"/>
-              <a:t>erreurs</a:t>
-            </a:r>
-            <a:r>
-              <a:rPr lang="en-US" sz="2000" dirty="0"/>
-              <a:t> </a:t>
-            </a:r>
-            <a:r>
-              <a:rPr lang="en-US" sz="2000" dirty="0" err="1"/>
-              <a:t>ou</a:t>
-            </a:r>
-            <a:r>
-              <a:rPr lang="en-US" sz="2000" dirty="0"/>
-              <a:t> des </a:t>
-            </a:r>
-            <a:r>
-              <a:rPr lang="en-US" sz="2000" dirty="0" err="1"/>
-              <a:t>risques</a:t>
-            </a:r>
-            <a:r>
-              <a:rPr lang="en-US" sz="2000" dirty="0"/>
-              <a:t> de sécurité. Notre </a:t>
-            </a:r>
-            <a:r>
-              <a:rPr lang="en-US" sz="2000" dirty="0" err="1"/>
-              <a:t>objectif</a:t>
-            </a:r>
-            <a:r>
-              <a:rPr lang="en-US" sz="2000" dirty="0"/>
-              <a:t> est </a:t>
-            </a:r>
-            <a:r>
-              <a:rPr lang="en-US" sz="2000" dirty="0" err="1"/>
-              <a:t>d'automatiser</a:t>
-            </a:r>
-            <a:r>
-              <a:rPr lang="en-US" sz="2000" dirty="0"/>
-              <a:t> </a:t>
-            </a:r>
-            <a:r>
-              <a:rPr lang="en-US" sz="2000" dirty="0" err="1"/>
-              <a:t>ces</a:t>
-            </a:r>
-            <a:r>
-              <a:rPr lang="en-US" sz="2000" dirty="0"/>
-              <a:t> processus </a:t>
-            </a:r>
-            <a:r>
-              <a:rPr lang="en-US" sz="2000" dirty="0" err="1"/>
-              <a:t>afin</a:t>
-            </a:r>
-            <a:r>
-              <a:rPr lang="en-US" sz="2000" dirty="0"/>
-              <a:t> de </a:t>
-            </a:r>
-            <a:r>
-              <a:rPr lang="en-US" sz="2000" dirty="0" err="1"/>
-              <a:t>réduire</a:t>
-            </a:r>
-            <a:r>
-              <a:rPr lang="en-US" sz="2000" dirty="0"/>
-              <a:t> les </a:t>
-            </a:r>
-            <a:r>
-              <a:rPr lang="en-US" sz="2000" dirty="0" err="1"/>
-              <a:t>risques</a:t>
-            </a:r>
-            <a:r>
-              <a:rPr lang="en-US" sz="2000" dirty="0"/>
-              <a:t> et </a:t>
-            </a:r>
-            <a:r>
-              <a:rPr lang="en-US" sz="2000" dirty="0" err="1"/>
-              <a:t>améliorer</a:t>
-            </a:r>
-            <a:r>
-              <a:rPr lang="en-US" sz="2000" dirty="0"/>
-              <a:t> </a:t>
-            </a:r>
-            <a:r>
-              <a:rPr lang="en-US" sz="2000" dirty="0" err="1"/>
-              <a:t>l'efficacité</a:t>
-            </a:r>
-            <a:r>
-              <a:rPr lang="en-US" sz="2000" dirty="0"/>
-              <a:t> </a:t>
-            </a:r>
-            <a:r>
-              <a:rPr lang="en-US" sz="2000" dirty="0" err="1"/>
-              <a:t>opérationnelle</a:t>
-            </a:r>
-            <a:r>
-              <a:rPr lang="en-US" sz="2000" dirty="0"/>
-              <a:t>.</a:t>
-            </a:r>
-          </a:p>
-          <a:p>
-            <a:endParaRPr lang="en-US" dirty="0"/>
+              <a:rPr lang="en-US" dirty="0" err="1"/>
+              <a:t>utilisé</a:t>
+            </a:r>
+            <a:r>
+              <a:rPr lang="en-US" dirty="0"/>
+              <a:t> PowerShell, Visual Studio Code, des </a:t>
+            </a:r>
+            <a:r>
+              <a:rPr lang="en-US" dirty="0" err="1"/>
+              <a:t>fichiers</a:t>
+            </a:r>
+            <a:r>
+              <a:rPr lang="en-US" dirty="0"/>
+              <a:t> CSV et un rapport HTML</a:t>
+            </a:r>
           </a:p>
         </p:txBody>
       </p:sp>
@@ -734,7 +738,7 @@
           <a:p>
             <a:fld id="{8CADF99C-AF7E-4688-B727-7B33BD5CCDA3}" type="slidenum">
               <a:rPr lang="en-US" smtClean="0"/>
-              <a:t>2</a:t>
+              <a:t>1</a:t>
             </a:fld>
             <a:endParaRPr lang="en-US"/>
           </a:p>
@@ -743,7 +747,238 @@
     </p:spTree>
     <p:extLst>
       <p:ext uri="{BB962C8B-B14F-4D97-AF65-F5344CB8AC3E}">
-        <p14:creationId xmlns:p14="http://schemas.microsoft.com/office/powerpoint/2010/main" val="3422279232"/>
+        <p14:creationId xmlns:p14="http://schemas.microsoft.com/office/powerpoint/2010/main" val="373943753"/>
+      </p:ext>
+    </p:extLst>
+  </p:cSld>
+  <p:clrMapOvr>
+    <a:masterClrMapping/>
+  </p:clrMapOvr>
+</p:notes>
+</file>
+
+<file path=ppt/notesSlides/notesSlide10.xml><?xml version="1.0" encoding="utf-8"?>
+<p:notes xmlns:a="http://schemas.openxmlformats.org/drawingml/2006/main" xmlns:r="http://schemas.openxmlformats.org/officeDocument/2006/relationships" xmlns:p="http://schemas.openxmlformats.org/presentationml/2006/main">
+  <p:cSld>
+    <p:spTree>
+      <p:nvGrpSpPr>
+        <p:cNvPr id="1" name=""/>
+        <p:cNvGrpSpPr/>
+        <p:nvPr/>
+      </p:nvGrpSpPr>
+      <p:grpSpPr>
+        <a:xfrm>
+          <a:off x="0" y="0"/>
+          <a:ext cx="0" cy="0"/>
+          <a:chOff x="0" y="0"/>
+          <a:chExt cx="0" cy="0"/>
+        </a:xfrm>
+      </p:grpSpPr>
+      <p:sp>
+        <p:nvSpPr>
+          <p:cNvPr id="2" name="Slide Image Placeholder 1"/>
+          <p:cNvSpPr>
+            <a:spLocks noGrp="1" noRot="1" noChangeAspect="1"/>
+          </p:cNvSpPr>
+          <p:nvPr>
+            <p:ph type="sldImg"/>
+          </p:nvPr>
+        </p:nvSpPr>
+        <p:spPr/>
+      </p:sp>
+      <p:sp>
+        <p:nvSpPr>
+          <p:cNvPr id="3" name="Notes Placeholder 2"/>
+          <p:cNvSpPr>
+            <a:spLocks noGrp="1"/>
+          </p:cNvSpPr>
+          <p:nvPr>
+            <p:ph type="body" idx="1"/>
+          </p:nvPr>
+        </p:nvSpPr>
+        <p:spPr/>
+        <p:txBody>
+          <a:bodyPr/>
+          <a:lstStyle/>
+          <a:p>
+            <a:r>
+              <a:rPr lang="fr-FR" dirty="0"/>
+              <a:t>Le rapport HTML permet de visualiser les résultats du traitement, les opérations réalisées ainsi que les erreurs détectées par le système. Il constitue également un élément important pour l'audit et la conformité.</a:t>
+            </a:r>
+            <a:endParaRPr lang="en-US" dirty="0"/>
+          </a:p>
+        </p:txBody>
+      </p:sp>
+      <p:sp>
+        <p:nvSpPr>
+          <p:cNvPr id="4" name="Slide Number Placeholder 3"/>
+          <p:cNvSpPr>
+            <a:spLocks noGrp="1"/>
+          </p:cNvSpPr>
+          <p:nvPr>
+            <p:ph type="sldNum" sz="quarter" idx="5"/>
+          </p:nvPr>
+        </p:nvSpPr>
+        <p:spPr/>
+        <p:txBody>
+          <a:bodyPr/>
+          <a:lstStyle/>
+          <a:p>
+            <a:fld id="{8CADF99C-AF7E-4688-B727-7B33BD5CCDA3}" type="slidenum">
+              <a:rPr lang="en-US" smtClean="0"/>
+              <a:t>10</a:t>
+            </a:fld>
+            <a:endParaRPr lang="en-US"/>
+          </a:p>
+        </p:txBody>
+      </p:sp>
+    </p:spTree>
+    <p:extLst>
+      <p:ext uri="{BB962C8B-B14F-4D97-AF65-F5344CB8AC3E}">
+        <p14:creationId xmlns:p14="http://schemas.microsoft.com/office/powerpoint/2010/main" val="1492159719"/>
+      </p:ext>
+    </p:extLst>
+  </p:cSld>
+  <p:clrMapOvr>
+    <a:masterClrMapping/>
+  </p:clrMapOvr>
+</p:notes>
+</file>
+
+<file path=ppt/notesSlides/notesSlide11.xml><?xml version="1.0" encoding="utf-8"?>
+<p:notes xmlns:a="http://schemas.openxmlformats.org/drawingml/2006/main" xmlns:r="http://schemas.openxmlformats.org/officeDocument/2006/relationships" xmlns:p="http://schemas.openxmlformats.org/presentationml/2006/main">
+  <p:cSld>
+    <p:spTree>
+      <p:nvGrpSpPr>
+        <p:cNvPr id="1" name=""/>
+        <p:cNvGrpSpPr/>
+        <p:nvPr/>
+      </p:nvGrpSpPr>
+      <p:grpSpPr>
+        <a:xfrm>
+          <a:off x="0" y="0"/>
+          <a:ext cx="0" cy="0"/>
+          <a:chOff x="0" y="0"/>
+          <a:chExt cx="0" cy="0"/>
+        </a:xfrm>
+      </p:grpSpPr>
+      <p:sp>
+        <p:nvSpPr>
+          <p:cNvPr id="2" name="Slide Image Placeholder 1"/>
+          <p:cNvSpPr>
+            <a:spLocks noGrp="1" noRot="1" noChangeAspect="1"/>
+          </p:cNvSpPr>
+          <p:nvPr>
+            <p:ph type="sldImg"/>
+          </p:nvPr>
+        </p:nvSpPr>
+        <p:spPr/>
+      </p:sp>
+      <p:sp>
+        <p:nvSpPr>
+          <p:cNvPr id="3" name="Notes Placeholder 2"/>
+          <p:cNvSpPr>
+            <a:spLocks noGrp="1"/>
+          </p:cNvSpPr>
+          <p:nvPr>
+            <p:ph type="body" idx="1"/>
+          </p:nvPr>
+        </p:nvSpPr>
+        <p:spPr/>
+        <p:txBody>
+          <a:bodyPr/>
+          <a:lstStyle/>
+          <a:p>
+            <a:r>
+              <a:rPr lang="en-US" dirty="0"/>
+              <a:t>Cette architecture </a:t>
+            </a:r>
+            <a:r>
+              <a:rPr lang="en-US" dirty="0" err="1"/>
+              <a:t>représente</a:t>
+            </a:r>
+            <a:r>
+              <a:rPr lang="en-US" dirty="0"/>
+              <a:t> </a:t>
+            </a:r>
+            <a:r>
+              <a:rPr lang="en-US" dirty="0" err="1"/>
+              <a:t>l'évolution</a:t>
+            </a:r>
+            <a:r>
+              <a:rPr lang="en-US" dirty="0"/>
+              <a:t> du MVP vers </a:t>
+            </a:r>
+            <a:r>
+              <a:rPr lang="en-US" dirty="0" err="1"/>
+              <a:t>une</a:t>
+            </a:r>
+            <a:r>
+              <a:rPr lang="en-US" dirty="0"/>
+              <a:t> solution </a:t>
+            </a:r>
+            <a:r>
+              <a:rPr lang="en-US" dirty="0" err="1"/>
+              <a:t>d'entreprise</a:t>
+            </a:r>
+            <a:r>
+              <a:rPr lang="en-US" dirty="0"/>
+              <a:t> </a:t>
+            </a:r>
+            <a:r>
+              <a:rPr lang="en-US" dirty="0" err="1"/>
+              <a:t>intégrant</a:t>
+            </a:r>
+            <a:r>
+              <a:rPr lang="en-US" dirty="0"/>
+              <a:t> Active Directory, Microsoft Entra ID, Microsoft 365, les </a:t>
+            </a:r>
+            <a:r>
+              <a:rPr lang="en-US" dirty="0" err="1"/>
+              <a:t>systèmes</a:t>
+            </a:r>
+            <a:r>
+              <a:rPr lang="en-US" dirty="0"/>
+              <a:t> RH et les </a:t>
+            </a:r>
+            <a:r>
+              <a:rPr lang="en-US" dirty="0" err="1"/>
+              <a:t>outils</a:t>
+            </a:r>
+            <a:r>
+              <a:rPr lang="en-US" dirty="0"/>
+              <a:t> ITSM.</a:t>
+            </a:r>
+          </a:p>
+        </p:txBody>
+      </p:sp>
+      <p:sp>
+        <p:nvSpPr>
+          <p:cNvPr id="4" name="Slide Number Placeholder 3"/>
+          <p:cNvSpPr>
+            <a:spLocks noGrp="1"/>
+          </p:cNvSpPr>
+          <p:nvPr>
+            <p:ph type="sldNum" sz="quarter" idx="5"/>
+          </p:nvPr>
+        </p:nvSpPr>
+        <p:spPr/>
+        <p:txBody>
+          <a:bodyPr/>
+          <a:lstStyle/>
+          <a:p>
+            <a:fld id="{8CADF99C-AF7E-4688-B727-7B33BD5CCDA3}" type="slidenum">
+              <a:rPr lang="en-US" smtClean="0"/>
+              <a:t>11</a:t>
+            </a:fld>
+            <a:endParaRPr lang="en-US"/>
+          </a:p>
+        </p:txBody>
+      </p:sp>
+    </p:spTree>
+    <p:extLst>
+      <p:ext uri="{BB962C8B-B14F-4D97-AF65-F5344CB8AC3E}">
+        <p14:creationId xmlns:p14="http://schemas.microsoft.com/office/powerpoint/2010/main" val="2736463003"/>
       </p:ext>
     </p:extLst>
   </p:cSld>
@@ -797,10 +1032,199 @@
           <a:bodyPr/>
           <a:lstStyle/>
           <a:p>
-            <a:r>
-              <a:rPr lang="fr-FR" dirty="0"/>
-              <a:t>Lorsqu'un nouvel employé rejoint l'organisation, le système valide les données RH, vérifie les règles RBAC, crée le compte utilisateur, attribue les groupes nécessaires et enregistre toutes les actions dans les journaux d'audit.</a:t>
-            </a:r>
+            <a:pPr>
+              <a:buNone/>
+            </a:pPr>
+            <a:r>
+              <a:rPr lang="en-US" sz="2000" dirty="0"/>
+              <a:t>Les </a:t>
+            </a:r>
+            <a:r>
+              <a:rPr lang="en-US" sz="2000" dirty="0" err="1"/>
+              <a:t>établissements</a:t>
+            </a:r>
+            <a:r>
+              <a:rPr lang="en-US" sz="2000" dirty="0"/>
+              <a:t> de santé </a:t>
+            </a:r>
+            <a:r>
+              <a:rPr lang="en-US" sz="2000" dirty="0" err="1"/>
+              <a:t>gèrent</a:t>
+            </a:r>
+            <a:r>
+              <a:rPr lang="en-US" sz="2000" dirty="0"/>
+              <a:t> des </a:t>
+            </a:r>
+            <a:r>
+              <a:rPr lang="en-US" sz="2000" dirty="0" err="1"/>
+              <a:t>centaines</a:t>
+            </a:r>
+            <a:r>
+              <a:rPr lang="en-US" sz="2000" dirty="0"/>
+              <a:t> </a:t>
+            </a:r>
+            <a:r>
+              <a:rPr lang="en-US" sz="2000" dirty="0" err="1"/>
+              <a:t>voire</a:t>
+            </a:r>
+            <a:r>
+              <a:rPr lang="en-US" sz="2000" dirty="0"/>
+              <a:t> des </a:t>
+            </a:r>
+            <a:r>
+              <a:rPr lang="en-US" sz="2000" dirty="0" err="1"/>
+              <a:t>milliers</a:t>
+            </a:r>
+            <a:r>
+              <a:rPr lang="en-US" sz="2000" dirty="0"/>
+              <a:t> </a:t>
+            </a:r>
+            <a:r>
+              <a:rPr lang="en-US" sz="2000" dirty="0" err="1"/>
+              <a:t>d'employés</a:t>
+            </a:r>
+            <a:r>
+              <a:rPr lang="en-US" sz="2000" dirty="0"/>
+              <a:t>. La </a:t>
+            </a:r>
+            <a:r>
+              <a:rPr lang="en-US" sz="2000" dirty="0" err="1"/>
+              <a:t>création</a:t>
+            </a:r>
+            <a:r>
+              <a:rPr lang="en-US" sz="2000" dirty="0"/>
+              <a:t> </a:t>
+            </a:r>
+            <a:r>
+              <a:rPr lang="en-US" sz="2000" dirty="0" err="1"/>
+              <a:t>manuelle</a:t>
+            </a:r>
+            <a:r>
+              <a:rPr lang="en-US" sz="2000" dirty="0"/>
+              <a:t> des </a:t>
+            </a:r>
+            <a:r>
+              <a:rPr lang="en-US" sz="2000" dirty="0" err="1"/>
+              <a:t>comptes</a:t>
+            </a:r>
+            <a:r>
+              <a:rPr lang="en-US" sz="2000" dirty="0"/>
+              <a:t> </a:t>
+            </a:r>
+            <a:r>
+              <a:rPr lang="en-US" sz="2000" dirty="0" err="1"/>
+              <a:t>peut</a:t>
+            </a:r>
+            <a:r>
+              <a:rPr lang="en-US" sz="2000" dirty="0"/>
+              <a:t> </a:t>
+            </a:r>
+            <a:r>
+              <a:rPr lang="en-US" sz="2000" dirty="0" err="1"/>
+              <a:t>entraîner</a:t>
+            </a:r>
+            <a:r>
+              <a:rPr lang="en-US" sz="2000" dirty="0"/>
+              <a:t> des retards, des </a:t>
+            </a:r>
+            <a:r>
+              <a:rPr lang="en-US" sz="2000" dirty="0" err="1"/>
+              <a:t>erreurs</a:t>
+            </a:r>
+            <a:r>
+              <a:rPr lang="en-US" sz="2000" dirty="0"/>
+              <a:t> </a:t>
+            </a:r>
+            <a:r>
+              <a:rPr lang="en-US" sz="2000" dirty="0" err="1"/>
+              <a:t>ou</a:t>
+            </a:r>
+            <a:r>
+              <a:rPr lang="en-US" sz="2000" dirty="0"/>
+              <a:t> des </a:t>
+            </a:r>
+            <a:r>
+              <a:rPr lang="en-US" sz="2000" dirty="0" err="1"/>
+              <a:t>risques</a:t>
+            </a:r>
+            <a:r>
+              <a:rPr lang="en-US" sz="2000" dirty="0"/>
+              <a:t> de sécurité. Notre </a:t>
+            </a:r>
+            <a:r>
+              <a:rPr lang="en-US" sz="2000" dirty="0" err="1"/>
+              <a:t>objectif</a:t>
+            </a:r>
+            <a:r>
+              <a:rPr lang="en-US" sz="2000" dirty="0"/>
+              <a:t> est </a:t>
+            </a:r>
+            <a:r>
+              <a:rPr lang="en-US" sz="2000" dirty="0" err="1"/>
+              <a:t>d'automatiser</a:t>
+            </a:r>
+            <a:r>
+              <a:rPr lang="en-US" sz="2000" dirty="0"/>
+              <a:t> </a:t>
+            </a:r>
+            <a:r>
+              <a:rPr lang="en-US" sz="2000" dirty="0" err="1"/>
+              <a:t>ces</a:t>
+            </a:r>
+            <a:r>
+              <a:rPr lang="en-US" sz="2000" dirty="0"/>
+              <a:t> processus </a:t>
+            </a:r>
+            <a:r>
+              <a:rPr lang="en-US" sz="2000" dirty="0" err="1"/>
+              <a:t>afin</a:t>
+            </a:r>
+            <a:r>
+              <a:rPr lang="en-US" sz="2000" dirty="0"/>
+              <a:t> de </a:t>
+            </a:r>
+            <a:r>
+              <a:rPr lang="en-US" sz="2000" dirty="0" err="1"/>
+              <a:t>réduire</a:t>
+            </a:r>
+            <a:r>
+              <a:rPr lang="en-US" sz="2000" dirty="0"/>
+              <a:t> les </a:t>
+            </a:r>
+            <a:r>
+              <a:rPr lang="en-US" sz="2000" dirty="0" err="1"/>
+              <a:t>risques</a:t>
+            </a:r>
+            <a:r>
+              <a:rPr lang="en-US" sz="2000" dirty="0"/>
+              <a:t> et </a:t>
+            </a:r>
+            <a:r>
+              <a:rPr lang="en-US" sz="2000" dirty="0" err="1"/>
+              <a:t>améliorer</a:t>
+            </a:r>
+            <a:r>
+              <a:rPr lang="en-US" sz="2000" dirty="0"/>
+              <a:t> </a:t>
+            </a:r>
+            <a:r>
+              <a:rPr lang="en-US" sz="2000" dirty="0" err="1"/>
+              <a:t>l'efficacité</a:t>
+            </a:r>
+            <a:r>
+              <a:rPr lang="en-US" sz="2000" dirty="0"/>
+              <a:t> </a:t>
+            </a:r>
+            <a:r>
+              <a:rPr lang="en-US" sz="2000" dirty="0" err="1"/>
+              <a:t>opérationnelle</a:t>
+            </a:r>
+            <a:r>
+              <a:rPr lang="en-US" sz="2000" dirty="0"/>
+              <a:t>.</a:t>
+            </a:r>
+          </a:p>
+          <a:p>
             <a:endParaRPr lang="en-US" dirty="0"/>
           </a:p>
         </p:txBody>
@@ -822,7 +1246,7 @@
           <a:p>
             <a:fld id="{8CADF99C-AF7E-4688-B727-7B33BD5CCDA3}" type="slidenum">
               <a:rPr lang="en-US" smtClean="0"/>
-              <a:t>5</a:t>
+              <a:t>2</a:t>
             </a:fld>
             <a:endParaRPr lang="en-US"/>
           </a:p>
@@ -831,7 +1255,7 @@
     </p:spTree>
     <p:extLst>
       <p:ext uri="{BB962C8B-B14F-4D97-AF65-F5344CB8AC3E}">
-        <p14:creationId xmlns:p14="http://schemas.microsoft.com/office/powerpoint/2010/main" val="4213608230"/>
+        <p14:creationId xmlns:p14="http://schemas.microsoft.com/office/powerpoint/2010/main" val="3422279232"/>
       </p:ext>
     </p:extLst>
   </p:cSld>
@@ -886,129 +1310,52 @@
           <a:lstStyle/>
           <a:p>
             <a:r>
-              <a:rPr lang="en-US" dirty="0"/>
-              <a:t>Le </a:t>
-            </a:r>
-            <a:r>
-              <a:rPr lang="en-US" dirty="0" err="1"/>
-              <a:t>système</a:t>
-            </a:r>
-            <a:r>
-              <a:rPr lang="en-US" dirty="0"/>
-              <a:t> applique le </a:t>
-            </a:r>
-            <a:r>
-              <a:rPr lang="en-US" dirty="0" err="1"/>
-              <a:t>principe</a:t>
-            </a:r>
-            <a:r>
-              <a:rPr lang="en-US" dirty="0"/>
-              <a:t> du </a:t>
-            </a:r>
-            <a:r>
-              <a:rPr lang="en-US" dirty="0" err="1"/>
-              <a:t>moindre</a:t>
-            </a:r>
-            <a:r>
-              <a:rPr lang="en-US" dirty="0"/>
-              <a:t> </a:t>
-            </a:r>
-            <a:r>
-              <a:rPr lang="en-US" dirty="0" err="1"/>
-              <a:t>privilège</a:t>
-            </a:r>
-            <a:r>
-              <a:rPr lang="en-US" dirty="0"/>
-              <a:t>. Les </a:t>
-            </a:r>
-            <a:r>
-              <a:rPr lang="en-US" dirty="0" err="1"/>
-              <a:t>accès</a:t>
-            </a:r>
-            <a:r>
-              <a:rPr lang="en-US" dirty="0"/>
-              <a:t> </a:t>
-            </a:r>
-            <a:r>
-              <a:rPr lang="en-US" dirty="0" err="1"/>
-              <a:t>sont</a:t>
-            </a:r>
-            <a:r>
-              <a:rPr lang="en-US" dirty="0"/>
-              <a:t> </a:t>
-            </a:r>
-            <a:r>
-              <a:rPr lang="en-US" dirty="0" err="1"/>
-              <a:t>attribués</a:t>
-            </a:r>
-            <a:r>
-              <a:rPr lang="en-US" dirty="0"/>
-              <a:t> </a:t>
-            </a:r>
-            <a:r>
-              <a:rPr lang="en-US" dirty="0" err="1"/>
-              <a:t>automatiquement</a:t>
-            </a:r>
-            <a:r>
-              <a:rPr lang="en-US" dirty="0"/>
-              <a:t> </a:t>
-            </a:r>
-            <a:r>
-              <a:rPr lang="en-US" dirty="0" err="1"/>
-              <a:t>selon</a:t>
-            </a:r>
-            <a:r>
-              <a:rPr lang="en-US" dirty="0"/>
-              <a:t> le </a:t>
-            </a:r>
-            <a:r>
-              <a:rPr lang="en-US" dirty="0" err="1"/>
-              <a:t>rôle</a:t>
-            </a:r>
-            <a:r>
-              <a:rPr lang="en-US" dirty="0"/>
-              <a:t> de </a:t>
-            </a:r>
-            <a:r>
-              <a:rPr lang="en-US" dirty="0" err="1"/>
-              <a:t>l'employé</a:t>
-            </a:r>
-            <a:r>
-              <a:rPr lang="en-US" dirty="0"/>
-              <a:t> </a:t>
-            </a:r>
-            <a:r>
-              <a:rPr lang="en-US" dirty="0" err="1"/>
-              <a:t>afin</a:t>
-            </a:r>
-            <a:r>
-              <a:rPr lang="en-US" dirty="0"/>
-              <a:t> de limiter les </a:t>
-            </a:r>
-            <a:r>
-              <a:rPr lang="en-US" dirty="0" err="1"/>
-              <a:t>accès</a:t>
-            </a:r>
-            <a:r>
-              <a:rPr lang="en-US" dirty="0"/>
-              <a:t> </a:t>
-            </a:r>
-            <a:r>
-              <a:rPr lang="en-US" dirty="0" err="1"/>
-              <a:t>excessifs</a:t>
-            </a:r>
-            <a:r>
-              <a:rPr lang="en-US" dirty="0"/>
-              <a:t> et </a:t>
-            </a:r>
-            <a:r>
-              <a:rPr lang="en-US" dirty="0" err="1"/>
-              <a:t>renforcer</a:t>
-            </a:r>
-            <a:r>
-              <a:rPr lang="en-US" dirty="0"/>
-              <a:t> la sécurité.</a:t>
-            </a:r>
+              <a:rPr lang="fr-CA" dirty="0"/>
+              <a:t>Processus de fonctionnement de la solution</a:t>
+            </a:r>
+            <a:br>
+              <a:rPr lang="fr-CA" dirty="0"/>
+            </a:br>
+            <a:r>
+              <a:rPr lang="fr-CA" dirty="0"/>
+              <a:t>RH: saisie des données</a:t>
+            </a:r>
+            <a:br>
+              <a:rPr lang="fr-CA" dirty="0"/>
+            </a:br>
+            <a:r>
+              <a:rPr lang="fr-CA" dirty="0"/>
+              <a:t>Validation: les contrôles de gouvernances </a:t>
+            </a:r>
+            <a:br>
+              <a:rPr lang="fr-CA" dirty="0"/>
+            </a:br>
+            <a:r>
+              <a:rPr lang="fr-CA" dirty="0"/>
+              <a:t>IAM Engine: moteur der gestion des Accès et des identité </a:t>
+            </a:r>
+            <a:br>
+              <a:rPr lang="fr-CA" dirty="0"/>
+            </a:br>
+            <a:r>
+              <a:rPr lang="fr-CA" dirty="0"/>
+              <a:t>RBAC: contrôles d'accès basé sur les rôles</a:t>
+            </a:r>
+            <a:br>
+              <a:rPr lang="fr-CA" dirty="0"/>
+            </a:br>
+            <a:r>
+              <a:rPr lang="fr-CA" dirty="0"/>
+              <a:t>Journal des audits</a:t>
+            </a:r>
+            <a:br>
+              <a:rPr lang="fr-CA" dirty="0"/>
+            </a:br>
+            <a:r>
+              <a:rPr lang="fr-CA" dirty="0"/>
+              <a:t>Rapport de visualisation des actions entreprises</a:t>
+            </a:r>
+            <a:endParaRPr lang="en-US" dirty="0"/>
           </a:p>
         </p:txBody>
       </p:sp>
@@ -1029,7 +1376,7 @@
           <a:p>
             <a:fld id="{8CADF99C-AF7E-4688-B727-7B33BD5CCDA3}" type="slidenum">
               <a:rPr lang="en-US" smtClean="0"/>
-              <a:t>8</a:t>
+              <a:t>3</a:t>
             </a:fld>
             <a:endParaRPr lang="en-US"/>
           </a:p>
@@ -1038,7 +1385,7 @@
     </p:spTree>
     <p:extLst>
       <p:ext uri="{BB962C8B-B14F-4D97-AF65-F5344CB8AC3E}">
-        <p14:creationId xmlns:p14="http://schemas.microsoft.com/office/powerpoint/2010/main" val="2516540216"/>
+        <p14:creationId xmlns:p14="http://schemas.microsoft.com/office/powerpoint/2010/main" val="2013323305"/>
       </p:ext>
     </p:extLst>
   </p:cSld>
@@ -1093,137 +1440,49 @@
           <a:lstStyle/>
           <a:p>
             <a:r>
-              <a:rPr lang="en-US" dirty="0"/>
-              <a:t>Avant toute </a:t>
-            </a:r>
-            <a:r>
-              <a:rPr lang="en-US" dirty="0" err="1"/>
-              <a:t>création</a:t>
-            </a:r>
-            <a:r>
-              <a:rPr lang="en-US" dirty="0"/>
-              <a:t> de compte, le </a:t>
-            </a:r>
-            <a:r>
-              <a:rPr lang="en-US" dirty="0" err="1"/>
-              <a:t>système</a:t>
-            </a:r>
-            <a:r>
-              <a:rPr lang="en-US" dirty="0"/>
-              <a:t> </a:t>
-            </a:r>
-            <a:r>
-              <a:rPr lang="en-US" dirty="0" err="1"/>
-              <a:t>vérifie</a:t>
-            </a:r>
-            <a:r>
-              <a:rPr lang="en-US" dirty="0"/>
-              <a:t> </a:t>
-            </a:r>
-            <a:r>
-              <a:rPr lang="en-US" dirty="0" err="1"/>
-              <a:t>que</a:t>
-            </a:r>
-            <a:r>
-              <a:rPr lang="en-US" dirty="0"/>
-              <a:t> les </a:t>
-            </a:r>
-            <a:r>
-              <a:rPr lang="en-US" dirty="0" err="1"/>
-              <a:t>informations</a:t>
-            </a:r>
-            <a:r>
-              <a:rPr lang="en-US" dirty="0"/>
-              <a:t> </a:t>
-            </a:r>
-            <a:r>
-              <a:rPr lang="en-US" dirty="0" err="1"/>
-              <a:t>essentielles</a:t>
-            </a:r>
-            <a:r>
-              <a:rPr lang="en-US" dirty="0"/>
-              <a:t> </a:t>
-            </a:r>
-            <a:r>
-              <a:rPr lang="en-US" dirty="0" err="1"/>
-              <a:t>sont</a:t>
-            </a:r>
-            <a:r>
-              <a:rPr lang="en-US" dirty="0"/>
-              <a:t> </a:t>
-            </a:r>
-            <a:r>
-              <a:rPr lang="en-US" dirty="0" err="1"/>
-              <a:t>présentes</a:t>
-            </a:r>
-            <a:r>
-              <a:rPr lang="en-US" dirty="0"/>
-              <a:t>. Si un </a:t>
-            </a:r>
-            <a:r>
-              <a:rPr lang="en-US" dirty="0" err="1"/>
-              <a:t>gestionnaire</a:t>
-            </a:r>
-            <a:r>
-              <a:rPr lang="en-US" dirty="0"/>
-              <a:t>, un département </a:t>
-            </a:r>
-            <a:r>
-              <a:rPr lang="en-US" dirty="0" err="1"/>
-              <a:t>ou</a:t>
-            </a:r>
-            <a:r>
-              <a:rPr lang="en-US" dirty="0"/>
-              <a:t> un </a:t>
-            </a:r>
-            <a:r>
-              <a:rPr lang="en-US" dirty="0" err="1"/>
-              <a:t>rôle</a:t>
-            </a:r>
-            <a:r>
-              <a:rPr lang="en-US" dirty="0"/>
-              <a:t> est </a:t>
-            </a:r>
-            <a:r>
-              <a:rPr lang="en-US" dirty="0" err="1"/>
-              <a:t>manquant</a:t>
-            </a:r>
-            <a:r>
-              <a:rPr lang="en-US" dirty="0"/>
-              <a:t>, le processus est </a:t>
-            </a:r>
-            <a:r>
-              <a:rPr lang="en-US" dirty="0" err="1"/>
-              <a:t>bloqué</a:t>
-            </a:r>
-            <a:r>
-              <a:rPr lang="en-US" dirty="0"/>
-              <a:t> </a:t>
-            </a:r>
-            <a:r>
-              <a:rPr lang="en-US" dirty="0" err="1"/>
-              <a:t>afin</a:t>
-            </a:r>
-            <a:r>
-              <a:rPr lang="en-US" dirty="0"/>
-              <a:t> </a:t>
-            </a:r>
-            <a:r>
-              <a:rPr lang="en-US" dirty="0" err="1"/>
-              <a:t>d'éviter</a:t>
-            </a:r>
-            <a:r>
-              <a:rPr lang="en-US" dirty="0"/>
-              <a:t> des </a:t>
-            </a:r>
-            <a:r>
-              <a:rPr lang="en-US" dirty="0" err="1"/>
-              <a:t>erreurs</a:t>
-            </a:r>
-            <a:r>
-              <a:rPr lang="en-US" dirty="0"/>
-              <a:t> de sécurité.</a:t>
-            </a:r>
+              <a:rPr lang="fr-CA" dirty="0"/>
+              <a:t>Employees.csv: référentiel des données saisies par les RH</a:t>
+            </a:r>
+            <a:br>
+              <a:rPr lang="fr-CA" dirty="0"/>
+            </a:br>
+            <a:r>
+              <a:rPr lang="fr-CA" dirty="0"/>
+              <a:t>Le moteur IAM: validation des données par les contrôles de gouvernances ( RBAC + données exactes)</a:t>
+            </a:r>
+            <a:br>
+              <a:rPr lang="fr-CA" dirty="0"/>
+            </a:br>
+            <a:r>
+              <a:rPr lang="fr-CA" dirty="0"/>
+              <a:t>RoleMappings.csv: le référentiel de rôles</a:t>
+            </a:r>
+            <a:br>
+              <a:rPr lang="fr-CA" dirty="0"/>
+            </a:br>
+            <a:r>
+              <a:rPr lang="fr-CA" dirty="0"/>
+              <a:t>simulated_users.csv:  le référentiel des utilisateurs</a:t>
+            </a:r>
+            <a:br>
+              <a:rPr lang="fr-CA" dirty="0"/>
+            </a:br>
+            <a:r>
+              <a:rPr lang="fr-CA" dirty="0"/>
+              <a:t>audit_log.csv: référentiel de </a:t>
+            </a:r>
+            <a:r>
+              <a:rPr lang="fr-FR" dirty="0"/>
+              <a:t>toutes les actions dans les journaux d'audit</a:t>
+            </a:r>
+            <a:br>
+              <a:rPr lang="fr-FR" dirty="0"/>
+            </a:br>
+            <a:r>
+              <a:rPr lang="fr-FR" dirty="0"/>
+              <a:t>HTML report: rapport HTML pour visualiser les résultats du traitement, les opérations réalisées ainsi que les erreurs détectées par le système</a:t>
+            </a:r>
+            <a:endParaRPr lang="en-US" dirty="0"/>
           </a:p>
         </p:txBody>
       </p:sp>
@@ -1244,7 +1503,7 @@
           <a:p>
             <a:fld id="{8CADF99C-AF7E-4688-B727-7B33BD5CCDA3}" type="slidenum">
               <a:rPr lang="en-US" smtClean="0"/>
-              <a:t>9</a:t>
+              <a:t>4</a:t>
             </a:fld>
             <a:endParaRPr lang="en-US"/>
           </a:p>
@@ -1253,7 +1512,7 @@
     </p:spTree>
     <p:extLst>
       <p:ext uri="{BB962C8B-B14F-4D97-AF65-F5344CB8AC3E}">
-        <p14:creationId xmlns:p14="http://schemas.microsoft.com/office/powerpoint/2010/main" val="4253024838"/>
+        <p14:creationId xmlns:p14="http://schemas.microsoft.com/office/powerpoint/2010/main" val="2579354217"/>
       </p:ext>
     </p:extLst>
   </p:cSld>
@@ -1308,65 +1567,20 @@
           <a:lstStyle/>
           <a:p>
             <a:r>
-              <a:rPr lang="en-US" dirty="0"/>
-              <a:t>Cette architecture </a:t>
-            </a:r>
-            <a:r>
-              <a:rPr lang="en-US" dirty="0" err="1"/>
-              <a:t>représente</a:t>
-            </a:r>
-            <a:r>
-              <a:rPr lang="en-US" dirty="0"/>
-              <a:t> </a:t>
-            </a:r>
-            <a:r>
-              <a:rPr lang="en-US" dirty="0" err="1"/>
-              <a:t>l'évolution</a:t>
-            </a:r>
-            <a:r>
-              <a:rPr lang="en-US" dirty="0"/>
-              <a:t> du MVP vers </a:t>
-            </a:r>
-            <a:r>
-              <a:rPr lang="en-US" dirty="0" err="1"/>
-              <a:t>une</a:t>
-            </a:r>
-            <a:r>
-              <a:rPr lang="en-US" dirty="0"/>
-              <a:t> solution </a:t>
-            </a:r>
-            <a:r>
-              <a:rPr lang="en-US" dirty="0" err="1"/>
-              <a:t>d'entreprise</a:t>
-            </a:r>
-            <a:r>
-              <a:rPr lang="en-US" dirty="0"/>
-              <a:t> </a:t>
-            </a:r>
-            <a:r>
-              <a:rPr lang="en-US" dirty="0" err="1"/>
-              <a:t>intégrant</a:t>
-            </a:r>
-            <a:r>
-              <a:rPr lang="en-US" dirty="0"/>
-              <a:t> Active Directory, Microsoft Entra ID, Microsoft 365, les </a:t>
-            </a:r>
-            <a:r>
-              <a:rPr lang="en-US" dirty="0" err="1"/>
-              <a:t>systèmes</a:t>
-            </a:r>
-            <a:r>
-              <a:rPr lang="en-US" dirty="0"/>
-              <a:t> RH et les </a:t>
-            </a:r>
-            <a:r>
-              <a:rPr lang="en-US" dirty="0" err="1"/>
-              <a:t>outils</a:t>
-            </a:r>
-            <a:r>
-              <a:rPr lang="en-US" dirty="0"/>
-              <a:t> ITSM.</a:t>
-            </a:r>
+              <a:rPr lang="fr-FR" dirty="0"/>
+              <a:t>Lorsqu'un nouvel employé rejoint l'organisation, le système valide les données RH, vérifie les règles RBAC, crée le compte utilisateur, attribue les groupes nécessaires et enregistre toutes les actions dans les journaux d'audit.</a:t>
+            </a:r>
+            <a:br>
+              <a:rPr lang="fr-FR" dirty="0"/>
+            </a:br>
+            <a:br>
+              <a:rPr lang="fr-FR" dirty="0"/>
+            </a:br>
+            <a:r>
+              <a:rPr lang="fr-FR" dirty="0"/>
+              <a:t>Le système commence par valider les informations fournies par les RH.</a:t>
+            </a:r>
+            <a:endParaRPr lang="en-US" dirty="0"/>
           </a:p>
         </p:txBody>
       </p:sp>
@@ -1387,7 +1601,7 @@
           <a:p>
             <a:fld id="{8CADF99C-AF7E-4688-B727-7B33BD5CCDA3}" type="slidenum">
               <a:rPr lang="en-US" smtClean="0"/>
-              <a:t>11</a:t>
+              <a:t>5</a:t>
             </a:fld>
             <a:endParaRPr lang="en-US"/>
           </a:p>
@@ -1396,7 +1610,677 @@
     </p:spTree>
     <p:extLst>
       <p:ext uri="{BB962C8B-B14F-4D97-AF65-F5344CB8AC3E}">
-        <p14:creationId xmlns:p14="http://schemas.microsoft.com/office/powerpoint/2010/main" val="2736463003"/>
+        <p14:creationId xmlns:p14="http://schemas.microsoft.com/office/powerpoint/2010/main" val="4213608230"/>
+      </p:ext>
+    </p:extLst>
+  </p:cSld>
+  <p:clrMapOvr>
+    <a:masterClrMapping/>
+  </p:clrMapOvr>
+</p:notes>
+</file>
+
+<file path=ppt/notesSlides/notesSlide6.xml><?xml version="1.0" encoding="utf-8"?>
+<p:notes xmlns:a="http://schemas.openxmlformats.org/drawingml/2006/main" xmlns:r="http://schemas.openxmlformats.org/officeDocument/2006/relationships" xmlns:p="http://schemas.openxmlformats.org/presentationml/2006/main">
+  <p:cSld>
+    <p:spTree>
+      <p:nvGrpSpPr>
+        <p:cNvPr id="1" name=""/>
+        <p:cNvGrpSpPr/>
+        <p:nvPr/>
+      </p:nvGrpSpPr>
+      <p:grpSpPr>
+        <a:xfrm>
+          <a:off x="0" y="0"/>
+          <a:ext cx="0" cy="0"/>
+          <a:chOff x="0" y="0"/>
+          <a:chExt cx="0" cy="0"/>
+        </a:xfrm>
+      </p:grpSpPr>
+      <p:sp>
+        <p:nvSpPr>
+          <p:cNvPr id="2" name="Slide Image Placeholder 1"/>
+          <p:cNvSpPr>
+            <a:spLocks noGrp="1" noRot="1" noChangeAspect="1"/>
+          </p:cNvSpPr>
+          <p:nvPr>
+            <p:ph type="sldImg"/>
+          </p:nvPr>
+        </p:nvSpPr>
+        <p:spPr/>
+      </p:sp>
+      <p:sp>
+        <p:nvSpPr>
+          <p:cNvPr id="3" name="Notes Placeholder 2"/>
+          <p:cNvSpPr>
+            <a:spLocks noGrp="1"/>
+          </p:cNvSpPr>
+          <p:nvPr>
+            <p:ph type="body" idx="1"/>
+          </p:nvPr>
+        </p:nvSpPr>
+        <p:spPr/>
+        <p:txBody>
+          <a:bodyPr/>
+          <a:lstStyle/>
+          <a:p>
+            <a:pPr marL="0" marR="0" lvl="0" indent="0" algn="l" defTabSz="914400" rtl="0" eaLnBrk="1" fontAlgn="auto" latinLnBrk="0" hangingPunct="1">
+              <a:lnSpc>
+                <a:spcPct val="100000"/>
+              </a:lnSpc>
+              <a:spcBef>
+                <a:spcPts val="0"/>
+              </a:spcBef>
+              <a:spcAft>
+                <a:spcPts val="0"/>
+              </a:spcAft>
+              <a:buClrTx/>
+              <a:buSzTx/>
+              <a:buFontTx/>
+              <a:buNone/>
+              <a:tabLst/>
+              <a:defRPr/>
+            </a:pPr>
+            <a:r>
+              <a:rPr lang="fr-FR" dirty="0"/>
+              <a:t>Lorsqu’une mobilité interne se fait dans l'organisation, le système valide les données RH, vérifie les règles RBAC, fait une mise à jour du rôle, attribue les groupes nécessaires et enregistre toutes les actions dans les journaux d'audit.</a:t>
+            </a:r>
+            <a:br>
+              <a:rPr lang="fr-FR" dirty="0"/>
+            </a:br>
+            <a:br>
+              <a:rPr lang="fr-FR" dirty="0"/>
+            </a:br>
+            <a:r>
+              <a:rPr lang="fr-FR" dirty="0"/>
+              <a:t>Le système commence par valider les informations fournies par les RH.</a:t>
+            </a:r>
+            <a:endParaRPr lang="en-US" dirty="0"/>
+          </a:p>
+          <a:p>
+            <a:endParaRPr lang="en-US" dirty="0"/>
+          </a:p>
+        </p:txBody>
+      </p:sp>
+      <p:sp>
+        <p:nvSpPr>
+          <p:cNvPr id="4" name="Slide Number Placeholder 3"/>
+          <p:cNvSpPr>
+            <a:spLocks noGrp="1"/>
+          </p:cNvSpPr>
+          <p:nvPr>
+            <p:ph type="sldNum" sz="quarter" idx="5"/>
+          </p:nvPr>
+        </p:nvSpPr>
+        <p:spPr/>
+        <p:txBody>
+          <a:bodyPr/>
+          <a:lstStyle/>
+          <a:p>
+            <a:fld id="{8CADF99C-AF7E-4688-B727-7B33BD5CCDA3}" type="slidenum">
+              <a:rPr lang="en-US" smtClean="0"/>
+              <a:t>6</a:t>
+            </a:fld>
+            <a:endParaRPr lang="en-US"/>
+          </a:p>
+        </p:txBody>
+      </p:sp>
+    </p:spTree>
+    <p:extLst>
+      <p:ext uri="{BB962C8B-B14F-4D97-AF65-F5344CB8AC3E}">
+        <p14:creationId xmlns:p14="http://schemas.microsoft.com/office/powerpoint/2010/main" val="4149853311"/>
+      </p:ext>
+    </p:extLst>
+  </p:cSld>
+  <p:clrMapOvr>
+    <a:masterClrMapping/>
+  </p:clrMapOvr>
+</p:notes>
+</file>
+
+<file path=ppt/notesSlides/notesSlide7.xml><?xml version="1.0" encoding="utf-8"?>
+<p:notes xmlns:a="http://schemas.openxmlformats.org/drawingml/2006/main" xmlns:r="http://schemas.openxmlformats.org/officeDocument/2006/relationships" xmlns:p="http://schemas.openxmlformats.org/presentationml/2006/main">
+  <p:cSld>
+    <p:spTree>
+      <p:nvGrpSpPr>
+        <p:cNvPr id="1" name=""/>
+        <p:cNvGrpSpPr/>
+        <p:nvPr/>
+      </p:nvGrpSpPr>
+      <p:grpSpPr>
+        <a:xfrm>
+          <a:off x="0" y="0"/>
+          <a:ext cx="0" cy="0"/>
+          <a:chOff x="0" y="0"/>
+          <a:chExt cx="0" cy="0"/>
+        </a:xfrm>
+      </p:grpSpPr>
+      <p:sp>
+        <p:nvSpPr>
+          <p:cNvPr id="2" name="Slide Image Placeholder 1"/>
+          <p:cNvSpPr>
+            <a:spLocks noGrp="1" noRot="1" noChangeAspect="1"/>
+          </p:cNvSpPr>
+          <p:nvPr>
+            <p:ph type="sldImg"/>
+          </p:nvPr>
+        </p:nvSpPr>
+        <p:spPr/>
+      </p:sp>
+      <p:sp>
+        <p:nvSpPr>
+          <p:cNvPr id="3" name="Notes Placeholder 2"/>
+          <p:cNvSpPr>
+            <a:spLocks noGrp="1"/>
+          </p:cNvSpPr>
+          <p:nvPr>
+            <p:ph type="body" idx="1"/>
+          </p:nvPr>
+        </p:nvSpPr>
+        <p:spPr/>
+        <p:txBody>
+          <a:bodyPr/>
+          <a:lstStyle/>
+          <a:p>
+            <a:pPr marL="0" marR="0" lvl="0" indent="0" algn="l" defTabSz="914400" rtl="0" eaLnBrk="1" fontAlgn="auto" latinLnBrk="0" hangingPunct="1">
+              <a:lnSpc>
+                <a:spcPct val="100000"/>
+              </a:lnSpc>
+              <a:spcBef>
+                <a:spcPts val="0"/>
+              </a:spcBef>
+              <a:spcAft>
+                <a:spcPts val="0"/>
+              </a:spcAft>
+              <a:buClrTx/>
+              <a:buSzTx/>
+              <a:buFontTx/>
+              <a:buNone/>
+              <a:tabLst/>
+              <a:defRPr/>
+            </a:pPr>
+            <a:r>
+              <a:rPr lang="fr-FR" dirty="0"/>
+              <a:t>Lorsqu’un départ d’employé est fait dans l'organisation, le système valide les données RH, vérifie les données employées ( validation manager ou département), désactivation du compte, retrait des groupes et enregistrement des actions dans les journaux d'audit.</a:t>
+            </a:r>
+            <a:br>
+              <a:rPr lang="fr-FR" dirty="0"/>
+            </a:br>
+            <a:br>
+              <a:rPr lang="fr-FR" dirty="0"/>
+            </a:br>
+            <a:r>
+              <a:rPr lang="fr-FR" dirty="0"/>
+              <a:t>Le système commence par valider les informations fournies par les RH.</a:t>
+            </a:r>
+            <a:endParaRPr lang="en-US" dirty="0"/>
+          </a:p>
+          <a:p>
+            <a:endParaRPr lang="en-US" dirty="0"/>
+          </a:p>
+        </p:txBody>
+      </p:sp>
+      <p:sp>
+        <p:nvSpPr>
+          <p:cNvPr id="4" name="Slide Number Placeholder 3"/>
+          <p:cNvSpPr>
+            <a:spLocks noGrp="1"/>
+          </p:cNvSpPr>
+          <p:nvPr>
+            <p:ph type="sldNum" sz="quarter" idx="5"/>
+          </p:nvPr>
+        </p:nvSpPr>
+        <p:spPr/>
+        <p:txBody>
+          <a:bodyPr/>
+          <a:lstStyle/>
+          <a:p>
+            <a:fld id="{8CADF99C-AF7E-4688-B727-7B33BD5CCDA3}" type="slidenum">
+              <a:rPr lang="en-US" smtClean="0"/>
+              <a:t>7</a:t>
+            </a:fld>
+            <a:endParaRPr lang="en-US"/>
+          </a:p>
+        </p:txBody>
+      </p:sp>
+    </p:spTree>
+    <p:extLst>
+      <p:ext uri="{BB962C8B-B14F-4D97-AF65-F5344CB8AC3E}">
+        <p14:creationId xmlns:p14="http://schemas.microsoft.com/office/powerpoint/2010/main" val="3515272549"/>
+      </p:ext>
+    </p:extLst>
+  </p:cSld>
+  <p:clrMapOvr>
+    <a:masterClrMapping/>
+  </p:clrMapOvr>
+</p:notes>
+</file>
+
+<file path=ppt/notesSlides/notesSlide8.xml><?xml version="1.0" encoding="utf-8"?>
+<p:notes xmlns:a="http://schemas.openxmlformats.org/drawingml/2006/main" xmlns:r="http://schemas.openxmlformats.org/officeDocument/2006/relationships" xmlns:p="http://schemas.openxmlformats.org/presentationml/2006/main">
+  <p:cSld>
+    <p:spTree>
+      <p:nvGrpSpPr>
+        <p:cNvPr id="1" name=""/>
+        <p:cNvGrpSpPr/>
+        <p:nvPr/>
+      </p:nvGrpSpPr>
+      <p:grpSpPr>
+        <a:xfrm>
+          <a:off x="0" y="0"/>
+          <a:ext cx="0" cy="0"/>
+          <a:chOff x="0" y="0"/>
+          <a:chExt cx="0" cy="0"/>
+        </a:xfrm>
+      </p:grpSpPr>
+      <p:sp>
+        <p:nvSpPr>
+          <p:cNvPr id="2" name="Slide Image Placeholder 1"/>
+          <p:cNvSpPr>
+            <a:spLocks noGrp="1" noRot="1" noChangeAspect="1"/>
+          </p:cNvSpPr>
+          <p:nvPr>
+            <p:ph type="sldImg"/>
+          </p:nvPr>
+        </p:nvSpPr>
+        <p:spPr/>
+      </p:sp>
+      <p:sp>
+        <p:nvSpPr>
+          <p:cNvPr id="3" name="Notes Placeholder 2"/>
+          <p:cNvSpPr>
+            <a:spLocks noGrp="1"/>
+          </p:cNvSpPr>
+          <p:nvPr>
+            <p:ph type="body" idx="1"/>
+          </p:nvPr>
+        </p:nvSpPr>
+        <p:spPr/>
+        <p:txBody>
+          <a:bodyPr/>
+          <a:lstStyle/>
+          <a:p>
+            <a:r>
+              <a:rPr lang="en-US" dirty="0"/>
+              <a:t>Le </a:t>
+            </a:r>
+            <a:r>
+              <a:rPr lang="en-US" dirty="0" err="1"/>
+              <a:t>système</a:t>
+            </a:r>
+            <a:r>
+              <a:rPr lang="en-US" dirty="0"/>
+              <a:t> applique le </a:t>
+            </a:r>
+            <a:r>
+              <a:rPr lang="en-US" dirty="0" err="1"/>
+              <a:t>principe</a:t>
+            </a:r>
+            <a:r>
+              <a:rPr lang="en-US" dirty="0"/>
+              <a:t> du </a:t>
+            </a:r>
+            <a:r>
+              <a:rPr lang="en-US" dirty="0" err="1"/>
+              <a:t>moindre</a:t>
+            </a:r>
+            <a:r>
+              <a:rPr lang="en-US" dirty="0"/>
+              <a:t> </a:t>
+            </a:r>
+            <a:r>
+              <a:rPr lang="en-US" dirty="0" err="1"/>
+              <a:t>privilège</a:t>
+            </a:r>
+            <a:r>
+              <a:rPr lang="en-US" dirty="0"/>
+              <a:t>. Les </a:t>
+            </a:r>
+            <a:r>
+              <a:rPr lang="en-US" dirty="0" err="1"/>
+              <a:t>accès</a:t>
+            </a:r>
+            <a:r>
+              <a:rPr lang="en-US" dirty="0"/>
+              <a:t> </a:t>
+            </a:r>
+            <a:r>
+              <a:rPr lang="en-US" dirty="0" err="1"/>
+              <a:t>sont</a:t>
+            </a:r>
+            <a:r>
+              <a:rPr lang="en-US" dirty="0"/>
+              <a:t> </a:t>
+            </a:r>
+            <a:r>
+              <a:rPr lang="en-US" dirty="0" err="1"/>
+              <a:t>attribués</a:t>
+            </a:r>
+            <a:r>
+              <a:rPr lang="en-US" dirty="0"/>
+              <a:t> </a:t>
+            </a:r>
+            <a:r>
+              <a:rPr lang="en-US" dirty="0" err="1"/>
+              <a:t>automatiquement</a:t>
+            </a:r>
+            <a:r>
+              <a:rPr lang="en-US" dirty="0"/>
+              <a:t> </a:t>
+            </a:r>
+            <a:r>
+              <a:rPr lang="en-US" dirty="0" err="1"/>
+              <a:t>selon</a:t>
+            </a:r>
+            <a:r>
+              <a:rPr lang="en-US" dirty="0"/>
+              <a:t> le </a:t>
+            </a:r>
+            <a:r>
+              <a:rPr lang="en-US" dirty="0" err="1"/>
+              <a:t>rôle</a:t>
+            </a:r>
+            <a:r>
+              <a:rPr lang="en-US" dirty="0"/>
+              <a:t> de </a:t>
+            </a:r>
+            <a:r>
+              <a:rPr lang="en-US" dirty="0" err="1"/>
+              <a:t>l'employé</a:t>
+            </a:r>
+            <a:r>
+              <a:rPr lang="en-US" dirty="0"/>
+              <a:t> </a:t>
+            </a:r>
+            <a:r>
+              <a:rPr lang="en-US" dirty="0" err="1"/>
+              <a:t>afin</a:t>
+            </a:r>
+            <a:r>
+              <a:rPr lang="en-US" dirty="0"/>
+              <a:t> de limiter les </a:t>
+            </a:r>
+            <a:r>
+              <a:rPr lang="en-US" dirty="0" err="1"/>
+              <a:t>accès</a:t>
+            </a:r>
+            <a:r>
+              <a:rPr lang="en-US" dirty="0"/>
+              <a:t> </a:t>
+            </a:r>
+            <a:r>
+              <a:rPr lang="en-US" dirty="0" err="1"/>
+              <a:t>excessifs</a:t>
+            </a:r>
+            <a:r>
+              <a:rPr lang="en-US" dirty="0"/>
+              <a:t> et </a:t>
+            </a:r>
+            <a:r>
+              <a:rPr lang="en-US" dirty="0" err="1"/>
+              <a:t>renforcer</a:t>
+            </a:r>
+            <a:r>
+              <a:rPr lang="en-US" dirty="0"/>
+              <a:t> la sécurité.</a:t>
+            </a:r>
+          </a:p>
+        </p:txBody>
+      </p:sp>
+      <p:sp>
+        <p:nvSpPr>
+          <p:cNvPr id="4" name="Slide Number Placeholder 3"/>
+          <p:cNvSpPr>
+            <a:spLocks noGrp="1"/>
+          </p:cNvSpPr>
+          <p:nvPr>
+            <p:ph type="sldNum" sz="quarter" idx="5"/>
+          </p:nvPr>
+        </p:nvSpPr>
+        <p:spPr/>
+        <p:txBody>
+          <a:bodyPr/>
+          <a:lstStyle/>
+          <a:p>
+            <a:fld id="{8CADF99C-AF7E-4688-B727-7B33BD5CCDA3}" type="slidenum">
+              <a:rPr lang="en-US" smtClean="0"/>
+              <a:t>8</a:t>
+            </a:fld>
+            <a:endParaRPr lang="en-US"/>
+          </a:p>
+        </p:txBody>
+      </p:sp>
+    </p:spTree>
+    <p:extLst>
+      <p:ext uri="{BB962C8B-B14F-4D97-AF65-F5344CB8AC3E}">
+        <p14:creationId xmlns:p14="http://schemas.microsoft.com/office/powerpoint/2010/main" val="2516540216"/>
+      </p:ext>
+    </p:extLst>
+  </p:cSld>
+  <p:clrMapOvr>
+    <a:masterClrMapping/>
+  </p:clrMapOvr>
+</p:notes>
+</file>
+
+<file path=ppt/notesSlides/notesSlide9.xml><?xml version="1.0" encoding="utf-8"?>
+<p:notes xmlns:a="http://schemas.openxmlformats.org/drawingml/2006/main" xmlns:r="http://schemas.openxmlformats.org/officeDocument/2006/relationships" xmlns:p="http://schemas.openxmlformats.org/presentationml/2006/main">
+  <p:cSld>
+    <p:spTree>
+      <p:nvGrpSpPr>
+        <p:cNvPr id="1" name=""/>
+        <p:cNvGrpSpPr/>
+        <p:nvPr/>
+      </p:nvGrpSpPr>
+      <p:grpSpPr>
+        <a:xfrm>
+          <a:off x="0" y="0"/>
+          <a:ext cx="0" cy="0"/>
+          <a:chOff x="0" y="0"/>
+          <a:chExt cx="0" cy="0"/>
+        </a:xfrm>
+      </p:grpSpPr>
+      <p:sp>
+        <p:nvSpPr>
+          <p:cNvPr id="2" name="Slide Image Placeholder 1"/>
+          <p:cNvSpPr>
+            <a:spLocks noGrp="1" noRot="1" noChangeAspect="1"/>
+          </p:cNvSpPr>
+          <p:nvPr>
+            <p:ph type="sldImg"/>
+          </p:nvPr>
+        </p:nvSpPr>
+        <p:spPr/>
+      </p:sp>
+      <p:sp>
+        <p:nvSpPr>
+          <p:cNvPr id="3" name="Notes Placeholder 2"/>
+          <p:cNvSpPr>
+            <a:spLocks noGrp="1"/>
+          </p:cNvSpPr>
+          <p:nvPr>
+            <p:ph type="body" idx="1"/>
+          </p:nvPr>
+        </p:nvSpPr>
+        <p:spPr/>
+        <p:txBody>
+          <a:bodyPr/>
+          <a:lstStyle/>
+          <a:p>
+            <a:r>
+              <a:rPr lang="en-US" dirty="0"/>
+              <a:t>Avant toute </a:t>
+            </a:r>
+            <a:r>
+              <a:rPr lang="en-US" dirty="0" err="1"/>
+              <a:t>création</a:t>
+            </a:r>
+            <a:r>
+              <a:rPr lang="en-US" dirty="0"/>
+              <a:t> de compte, le </a:t>
+            </a:r>
+            <a:r>
+              <a:rPr lang="en-US" dirty="0" err="1"/>
+              <a:t>système</a:t>
+            </a:r>
+            <a:r>
+              <a:rPr lang="en-US" dirty="0"/>
+              <a:t> </a:t>
+            </a:r>
+            <a:r>
+              <a:rPr lang="en-US" dirty="0" err="1"/>
+              <a:t>vérifie</a:t>
+            </a:r>
+            <a:r>
+              <a:rPr lang="en-US" dirty="0"/>
+              <a:t> </a:t>
+            </a:r>
+            <a:r>
+              <a:rPr lang="en-US" dirty="0" err="1"/>
+              <a:t>que</a:t>
+            </a:r>
+            <a:r>
+              <a:rPr lang="en-US" dirty="0"/>
+              <a:t> les </a:t>
+            </a:r>
+            <a:r>
+              <a:rPr lang="en-US" dirty="0" err="1"/>
+              <a:t>informations</a:t>
+            </a:r>
+            <a:r>
+              <a:rPr lang="en-US" dirty="0"/>
+              <a:t> </a:t>
+            </a:r>
+            <a:r>
+              <a:rPr lang="en-US" dirty="0" err="1"/>
+              <a:t>essentielles</a:t>
+            </a:r>
+            <a:r>
+              <a:rPr lang="en-US" dirty="0"/>
+              <a:t> </a:t>
+            </a:r>
+            <a:r>
+              <a:rPr lang="en-US" dirty="0" err="1"/>
+              <a:t>sont</a:t>
+            </a:r>
+            <a:r>
+              <a:rPr lang="en-US" dirty="0"/>
+              <a:t> </a:t>
+            </a:r>
+            <a:r>
+              <a:rPr lang="en-US" dirty="0" err="1"/>
+              <a:t>présentes</a:t>
+            </a:r>
+            <a:r>
+              <a:rPr lang="en-US" dirty="0"/>
+              <a:t>. Si un </a:t>
+            </a:r>
+            <a:r>
+              <a:rPr lang="en-US" dirty="0" err="1"/>
+              <a:t>gestionnaire</a:t>
+            </a:r>
+            <a:r>
+              <a:rPr lang="en-US" dirty="0"/>
+              <a:t>, un département </a:t>
+            </a:r>
+            <a:r>
+              <a:rPr lang="en-US" dirty="0" err="1"/>
+              <a:t>ou</a:t>
+            </a:r>
+            <a:r>
+              <a:rPr lang="en-US" dirty="0"/>
+              <a:t> un </a:t>
+            </a:r>
+            <a:r>
+              <a:rPr lang="en-US" dirty="0" err="1"/>
+              <a:t>rôle</a:t>
+            </a:r>
+            <a:r>
+              <a:rPr lang="en-US" dirty="0"/>
+              <a:t> est </a:t>
+            </a:r>
+            <a:r>
+              <a:rPr lang="en-US" dirty="0" err="1"/>
+              <a:t>manquant</a:t>
+            </a:r>
+            <a:r>
+              <a:rPr lang="en-US" dirty="0"/>
+              <a:t>, le processus est </a:t>
+            </a:r>
+            <a:r>
+              <a:rPr lang="en-US" dirty="0" err="1"/>
+              <a:t>bloqué</a:t>
+            </a:r>
+            <a:r>
+              <a:rPr lang="en-US" dirty="0"/>
+              <a:t> </a:t>
+            </a:r>
+            <a:r>
+              <a:rPr lang="en-US" dirty="0" err="1"/>
+              <a:t>afin</a:t>
+            </a:r>
+            <a:r>
+              <a:rPr lang="en-US" dirty="0"/>
+              <a:t> </a:t>
+            </a:r>
+            <a:r>
+              <a:rPr lang="en-US" dirty="0" err="1"/>
+              <a:t>d'éviter</a:t>
+            </a:r>
+            <a:r>
+              <a:rPr lang="en-US" dirty="0"/>
+              <a:t> des </a:t>
+            </a:r>
+            <a:r>
+              <a:rPr lang="en-US" dirty="0" err="1"/>
+              <a:t>erreurs</a:t>
+            </a:r>
+            <a:r>
+              <a:rPr lang="en-US" dirty="0"/>
+              <a:t> de sécurité.</a:t>
+            </a:r>
+            <a:br>
+              <a:rPr lang="en-US" dirty="0"/>
+            </a:br>
+            <a:r>
+              <a:rPr lang="en-US" dirty="0"/>
+              <a:t>Message de validation </a:t>
+            </a:r>
+            <a:r>
+              <a:rPr lang="en-US" dirty="0" err="1"/>
+              <a:t>indiqué</a:t>
+            </a:r>
+            <a:endParaRPr lang="en-US" dirty="0"/>
+          </a:p>
+        </p:txBody>
+      </p:sp>
+      <p:sp>
+        <p:nvSpPr>
+          <p:cNvPr id="4" name="Slide Number Placeholder 3"/>
+          <p:cNvSpPr>
+            <a:spLocks noGrp="1"/>
+          </p:cNvSpPr>
+          <p:nvPr>
+            <p:ph type="sldNum" sz="quarter" idx="5"/>
+          </p:nvPr>
+        </p:nvSpPr>
+        <p:spPr/>
+        <p:txBody>
+          <a:bodyPr/>
+          <a:lstStyle/>
+          <a:p>
+            <a:fld id="{8CADF99C-AF7E-4688-B727-7B33BD5CCDA3}" type="slidenum">
+              <a:rPr lang="en-US" smtClean="0"/>
+              <a:t>9</a:t>
+            </a:fld>
+            <a:endParaRPr lang="en-US"/>
+          </a:p>
+        </p:txBody>
+      </p:sp>
+    </p:spTree>
+    <p:extLst>
+      <p:ext uri="{BB962C8B-B14F-4D97-AF65-F5344CB8AC3E}">
+        <p14:creationId xmlns:p14="http://schemas.microsoft.com/office/powerpoint/2010/main" val="4253024838"/>
       </p:ext>
     </p:extLst>
   </p:cSld>
@@ -5199,7 +6083,7 @@
           <p:nvPr/>
         </p:nvPicPr>
         <p:blipFill>
-          <a:blip r:embed="rId2"/>
+          <a:blip r:embed="rId3"/>
           <a:stretch>
             <a:fillRect/>
           </a:stretch>
@@ -6585,8 +7469,8 @@
         </p:blipFill>
         <p:spPr>
           <a:xfrm>
-            <a:off x="6249373" y="467208"/>
-            <a:ext cx="3731857" cy="5923584"/>
+            <a:off x="5251939" y="467207"/>
+            <a:ext cx="5008708" cy="6273561"/>
           </a:xfrm>
           <a:prstGeom prst="rect">
             <a:avLst/>
@@ -7932,43 +8816,6 @@
           </a:p>
         </p:txBody>
       </p:sp>
-      <p:sp>
-        <p:nvSpPr>
-          <p:cNvPr id="7" name="Subtitle 6">
-            <a:extLst>
-              <a:ext uri="{FF2B5EF4-FFF2-40B4-BE49-F238E27FC236}">
-                <a16:creationId xmlns:a16="http://schemas.microsoft.com/office/drawing/2014/main" id="{BB06E2AE-6DB9-FDE5-F89B-EAD160B0D055}"/>
-              </a:ext>
-            </a:extLst>
-          </p:cNvPr>
-          <p:cNvSpPr>
-            <a:spLocks noGrp="1"/>
-          </p:cNvSpPr>
-          <p:nvPr>
-            <p:ph type="subTitle" idx="1"/>
-          </p:nvPr>
-        </p:nvSpPr>
-        <p:spPr>
-          <a:xfrm>
-            <a:off x="1105661" y="4800600"/>
-            <a:ext cx="5179879" cy="1200149"/>
-          </a:xfrm>
-        </p:spPr>
-        <p:txBody>
-          <a:bodyPr anchor="t">
-            <a:normAutofit/>
-          </a:bodyPr>
-          <a:lstStyle/>
-          <a:p>
-            <a:pPr algn="l"/>
-            <a:endParaRPr lang="en-US">
-              <a:solidFill>
-                <a:srgbClr val="FFFFFF"/>
-              </a:solidFill>
-            </a:endParaRPr>
-          </a:p>
-        </p:txBody>
-      </p:sp>
       <p:pic>
         <p:nvPicPr>
           <p:cNvPr id="5" name="Picture 4">
@@ -7984,7 +8831,7 @@
           <p:nvPr/>
         </p:nvPicPr>
         <p:blipFill>
-          <a:blip r:embed="rId2"/>
+          <a:blip r:embed="rId3"/>
           <a:stretch>
             <a:fillRect/>
           </a:stretch>
@@ -8438,7 +9285,7 @@
           <p:nvPr/>
         </p:nvPicPr>
         <p:blipFill>
-          <a:blip r:embed="rId2"/>
+          <a:blip r:embed="rId3"/>
           <a:stretch>
             <a:fillRect/>
           </a:stretch>
@@ -8988,8 +9835,8 @@
         </p:nvSpPr>
         <p:spPr>
           <a:xfrm>
-            <a:off x="660041" y="2767106"/>
-            <a:ext cx="2880828" cy="3071906"/>
+            <a:off x="112734" y="2767106"/>
+            <a:ext cx="3695178" cy="2481299"/>
           </a:xfrm>
         </p:spPr>
         <p:txBody>
@@ -9000,13 +9847,64 @@
           <a:p>
             <a:pPr algn="l"/>
             <a:r>
-              <a:rPr lang="en-US" sz="4000">
+              <a:rPr lang="en-US" sz="4000" dirty="0">
                 <a:solidFill>
                   <a:srgbClr val="FFFFFF"/>
                 </a:solidFill>
               </a:rPr>
               <a:t>Joiner Workflow</a:t>
             </a:r>
+            <a:br>
+              <a:rPr lang="en-US" sz="4000" dirty="0">
+                <a:solidFill>
+                  <a:srgbClr val="FFFFFF"/>
+                </a:solidFill>
+              </a:rPr>
+            </a:br>
+            <a:br>
+              <a:rPr lang="en-US" sz="4000" dirty="0">
+                <a:solidFill>
+                  <a:srgbClr val="FFFFFF"/>
+                </a:solidFill>
+              </a:rPr>
+            </a:br>
+            <a:r>
+              <a:rPr lang="en-US" sz="4000" dirty="0">
+                <a:solidFill>
+                  <a:srgbClr val="FFFFFF"/>
+                </a:solidFill>
+              </a:rPr>
+              <a:t>: </a:t>
+            </a:r>
+            <a:r>
+              <a:rPr lang="en-US" sz="4000" dirty="0" err="1">
+                <a:solidFill>
+                  <a:srgbClr val="FFFFFF"/>
+                </a:solidFill>
+              </a:rPr>
+              <a:t>Arrivées</a:t>
+            </a:r>
+            <a:r>
+              <a:rPr lang="en-US" sz="4000" dirty="0">
+                <a:solidFill>
+                  <a:srgbClr val="FFFFFF"/>
+                </a:solidFill>
+              </a:rPr>
+              <a:t> des </a:t>
+            </a:r>
+            <a:r>
+              <a:rPr lang="en-US" sz="4000" dirty="0" err="1">
+                <a:solidFill>
+                  <a:srgbClr val="FFFFFF"/>
+                </a:solidFill>
+              </a:rPr>
+              <a:t>employés</a:t>
+            </a:r>
+            <a:endParaRPr lang="en-US" sz="4000" dirty="0">
+              <a:solidFill>
+                <a:srgbClr val="FFFFFF"/>
+              </a:solidFill>
+            </a:endParaRPr>
           </a:p>
         </p:txBody>
       </p:sp>
@@ -9069,8 +9967,8 @@
         </p:blipFill>
         <p:spPr>
           <a:xfrm>
-            <a:off x="4870988" y="0"/>
-            <a:ext cx="6386292" cy="6705600"/>
+            <a:off x="4870988" y="274084"/>
+            <a:ext cx="6125258" cy="6431515"/>
           </a:xfrm>
           <a:prstGeom prst="rect">
             <a:avLst/>
@@ -9612,8 +10510,8 @@
         </p:nvSpPr>
         <p:spPr>
           <a:xfrm>
-            <a:off x="660041" y="2767106"/>
-            <a:ext cx="2880828" cy="3071906"/>
+            <a:off x="175364" y="2767106"/>
+            <a:ext cx="3757809" cy="3071906"/>
           </a:xfrm>
         </p:spPr>
         <p:txBody>
@@ -9624,12 +10522,66 @@
           <a:p>
             <a:pPr algn="l"/>
             <a:r>
-              <a:rPr lang="en-US" sz="4000">
+              <a:rPr lang="en-US" sz="4000" dirty="0">
                 <a:solidFill>
                   <a:srgbClr val="FFFFFF"/>
                 </a:solidFill>
               </a:rPr>
-              <a:t>Mover Workflow</a:t>
+              <a:t>Mover Workflow:</a:t>
+            </a:r>
+            <a:br>
+              <a:rPr lang="en-US" sz="4000" dirty="0">
+                <a:solidFill>
+                  <a:srgbClr val="FFFFFF"/>
+                </a:solidFill>
+              </a:rPr>
+            </a:br>
+            <a:br>
+              <a:rPr lang="en-US" sz="4000" dirty="0">
+                <a:solidFill>
+                  <a:srgbClr val="FFFFFF"/>
+                </a:solidFill>
+              </a:rPr>
+            </a:br>
+            <a:r>
+              <a:rPr lang="en-US" sz="4000" dirty="0">
+                <a:solidFill>
+                  <a:srgbClr val="FFFFFF"/>
+                </a:solidFill>
+              </a:rPr>
+              <a:t>changement de poste </a:t>
+            </a:r>
+            <a:r>
+              <a:rPr lang="en-US" sz="4000" dirty="0" err="1">
+                <a:solidFill>
+                  <a:srgbClr val="FFFFFF"/>
+                </a:solidFill>
+              </a:rPr>
+              <a:t>ou</a:t>
+            </a:r>
+            <a:r>
+              <a:rPr lang="en-US" sz="4000" dirty="0">
+                <a:solidFill>
+                  <a:srgbClr val="FFFFFF"/>
+                </a:solidFill>
+              </a:rPr>
+              <a:t> </a:t>
+            </a:r>
+            <a:r>
+              <a:rPr lang="en-US" sz="4000" dirty="0" err="1">
+                <a:solidFill>
+                  <a:srgbClr val="FFFFFF"/>
+                </a:solidFill>
+              </a:rPr>
+              <a:t>mobilité</a:t>
+            </a:r>
+            <a:r>
+              <a:rPr lang="en-US" sz="4000" dirty="0">
+                <a:solidFill>
+                  <a:srgbClr val="FFFFFF"/>
+                </a:solidFill>
+              </a:rPr>
+              <a:t> interne</a:t>
             </a:r>
           </a:p>
         </p:txBody>
@@ -9686,15 +10638,15 @@
           <p:nvPr/>
         </p:nvPicPr>
         <p:blipFill>
-          <a:blip r:embed="rId2"/>
+          <a:blip r:embed="rId3"/>
           <a:stretch>
             <a:fillRect/>
           </a:stretch>
         </p:blipFill>
         <p:spPr>
           <a:xfrm>
-            <a:off x="5156965" y="280067"/>
-            <a:ext cx="5328155" cy="6595752"/>
+            <a:off x="5156965" y="-18881"/>
+            <a:ext cx="5569650" cy="6894700"/>
           </a:xfrm>
           <a:prstGeom prst="rect">
             <a:avLst/>
@@ -10248,13 +11200,56 @@
           <a:p>
             <a:pPr algn="l"/>
             <a:r>
-              <a:rPr lang="en-US" sz="4000">
+              <a:rPr lang="en-US" sz="4000" dirty="0">
                 <a:solidFill>
                   <a:srgbClr val="FFFFFF"/>
                 </a:solidFill>
               </a:rPr>
               <a:t>Leaver Workflow</a:t>
             </a:r>
+            <a:br>
+              <a:rPr lang="en-US" sz="4000" dirty="0">
+                <a:solidFill>
+                  <a:srgbClr val="FFFFFF"/>
+                </a:solidFill>
+              </a:rPr>
+            </a:br>
+            <a:br>
+              <a:rPr lang="en-US" sz="4000" dirty="0">
+                <a:solidFill>
+                  <a:srgbClr val="FFFFFF"/>
+                </a:solidFill>
+              </a:rPr>
+            </a:br>
+            <a:r>
+              <a:rPr lang="en-US" sz="4000" dirty="0" err="1">
+                <a:solidFill>
+                  <a:srgbClr val="FFFFFF"/>
+                </a:solidFill>
+              </a:rPr>
+              <a:t>Départ</a:t>
+            </a:r>
+            <a:r>
+              <a:rPr lang="en-US" sz="4000" dirty="0">
+                <a:solidFill>
+                  <a:srgbClr val="FFFFFF"/>
+                </a:solidFill>
+              </a:rPr>
+              <a:t> des </a:t>
+            </a:r>
+            <a:r>
+              <a:rPr lang="en-US" sz="4000" dirty="0" err="1">
+                <a:solidFill>
+                  <a:srgbClr val="FFFFFF"/>
+                </a:solidFill>
+              </a:rPr>
+              <a:t>employés</a:t>
+            </a:r>
+            <a:endParaRPr lang="en-US" sz="4000" dirty="0">
+              <a:solidFill>
+                <a:srgbClr val="FFFFFF"/>
+              </a:solidFill>
+            </a:endParaRPr>
           </a:p>
         </p:txBody>
       </p:sp>
@@ -10310,7 +11305,7 @@
           <p:nvPr/>
         </p:nvPicPr>
         <p:blipFill>
-          <a:blip r:embed="rId2"/>
+          <a:blip r:embed="rId3"/>
           <a:stretch>
             <a:fillRect/>
           </a:stretch>

</xml_diff>